<commit_message>
feat: implement CI/CD deployment pipeline and integrate ds-sis design tokens into example consumption project
</commit_message>
<xml_diff>
--- a/apresentacao/DS-MS-Apresentacao.pptx
+++ b/apresentacao/DS-MS-Apresentacao.pptx
@@ -5,7 +5,7 @@
     <p:sldMasterId id="2147483648" r:id="rId1"/>
   </p:sldMasterIdLst>
   <p:notesMasterIdLst>
-    <p:notesMasterId r:id="rId7"/>
+    <p:notesMasterId r:id="rId9"/>
   </p:notesMasterIdLst>
   <p:sldIdLst>
     <p:sldId id="256" r:id="rId2"/>
@@ -13,6 +13,8 @@
     <p:sldId id="258" r:id="rId4"/>
     <p:sldId id="259" r:id="rId5"/>
     <p:sldId id="260" r:id="rId6"/>
+    <p:sldId id="261" r:id="rId7"/>
+    <p:sldId id="262" r:id="rId8"/>
   </p:sldIdLst>
   <p:sldSz cx="12188825" cy="6858000"/>
   <p:notesSz cx="6858000" cy="12188825"/>
@@ -141,7 +143,7 @@
     </p:spTree>
     <p:extLst>
       <p:ext uri="{BB962C8B-B14F-4D97-AF65-F5344CB8AC3E}">
-        <p14:creationId xmlns:p14="http://schemas.microsoft.com/office/powerpoint/2010/main" val="582140631"/>
+        <p14:creationId xmlns:p14="http://schemas.microsoft.com/office/powerpoint/2010/main" val="3456235454"/>
       </p:ext>
     </p:extLst>
   </p:cSld>
@@ -661,6 +663,174 @@
 </p:notes>
 </file>
 
+<file path=ppt/notesSlides/notesSlide6.xml><?xml version="1.0" encoding="utf-8"?>
+<p:notes xmlns:a="http://schemas.openxmlformats.org/drawingml/2006/main" xmlns:r="http://schemas.openxmlformats.org/officeDocument/2006/relationships" xmlns:p="http://schemas.openxmlformats.org/presentationml/2006/main">
+  <p:cSld>
+    <p:spTree>
+      <p:nvGrpSpPr>
+        <p:cNvPr id="1" name=""/>
+        <p:cNvGrpSpPr/>
+        <p:nvPr/>
+      </p:nvGrpSpPr>
+      <p:grpSpPr>
+        <a:xfrm>
+          <a:off x="0" y="0"/>
+          <a:ext cx="0" cy="0"/>
+          <a:chOff x="0" y="0"/>
+          <a:chExt cx="0" cy="0"/>
+        </a:xfrm>
+      </p:grpSpPr>
+      <p:sp>
+        <p:nvSpPr>
+          <p:cNvPr id="2" name="Slide Image Placeholder 1"/>
+          <p:cNvSpPr>
+            <a:spLocks noGrp="1" noRot="1" noChangeAspect="1"/>
+          </p:cNvSpPr>
+          <p:nvPr>
+            <p:ph type="sldImg"/>
+          </p:nvPr>
+        </p:nvSpPr>
+        <p:spPr/>
+      </p:sp>
+      <p:sp>
+        <p:nvSpPr>
+          <p:cNvPr id="3" name="Notes Placeholder 2"/>
+          <p:cNvSpPr>
+            <a:spLocks noGrp="1"/>
+          </p:cNvSpPr>
+          <p:nvPr>
+            <p:ph type="body" idx="1"/>
+          </p:nvPr>
+        </p:nvSpPr>
+        <p:spPr/>
+        <p:txBody>
+          <a:bodyPr/>
+          <a:lstStyle/>
+          <a:p>
+            <a:endParaRPr lang="en-US" dirty="0"/>
+          </a:p>
+        </p:txBody>
+      </p:sp>
+      <p:sp>
+        <p:nvSpPr>
+          <p:cNvPr id="4" name="Slide Number Placeholder 3"/>
+          <p:cNvSpPr>
+            <a:spLocks noGrp="1"/>
+          </p:cNvSpPr>
+          <p:nvPr>
+            <p:ph type="sldNum" sz="quarter" idx="10"/>
+          </p:nvPr>
+        </p:nvSpPr>
+        <p:spPr/>
+        <p:txBody>
+          <a:bodyPr/>
+          <a:lstStyle/>
+          <a:p>
+            <a:fld id="{F7021451-1387-4CA6-816F-3879F97B5CBC}" type="slidenum">
+              <a:rPr lang="en-US"/>
+              <a:t>6</a:t>
+            </a:fld>
+            <a:endParaRPr lang="en-US"/>
+          </a:p>
+        </p:txBody>
+      </p:sp>
+    </p:spTree>
+    <p:extLst>
+      <p:ext uri="{BB962C8B-B14F-4D97-AF65-F5344CB8AC3E}">
+        <p14:creationId xmlns:p14="http://schemas.microsoft.com/office/powerpoint/2010/main" val="1024086991"/>
+      </p:ext>
+    </p:extLst>
+  </p:cSld>
+  <p:clrMapOvr>
+    <a:masterClrMapping/>
+  </p:clrMapOvr>
+</p:notes>
+</file>
+
+<file path=ppt/notesSlides/notesSlide7.xml><?xml version="1.0" encoding="utf-8"?>
+<p:notes xmlns:a="http://schemas.openxmlformats.org/drawingml/2006/main" xmlns:r="http://schemas.openxmlformats.org/officeDocument/2006/relationships" xmlns:p="http://schemas.openxmlformats.org/presentationml/2006/main">
+  <p:cSld>
+    <p:spTree>
+      <p:nvGrpSpPr>
+        <p:cNvPr id="1" name=""/>
+        <p:cNvGrpSpPr/>
+        <p:nvPr/>
+      </p:nvGrpSpPr>
+      <p:grpSpPr>
+        <a:xfrm>
+          <a:off x="0" y="0"/>
+          <a:ext cx="0" cy="0"/>
+          <a:chOff x="0" y="0"/>
+          <a:chExt cx="0" cy="0"/>
+        </a:xfrm>
+      </p:grpSpPr>
+      <p:sp>
+        <p:nvSpPr>
+          <p:cNvPr id="2" name="Slide Image Placeholder 1"/>
+          <p:cNvSpPr>
+            <a:spLocks noGrp="1" noRot="1" noChangeAspect="1"/>
+          </p:cNvSpPr>
+          <p:nvPr>
+            <p:ph type="sldImg"/>
+          </p:nvPr>
+        </p:nvSpPr>
+        <p:spPr/>
+      </p:sp>
+      <p:sp>
+        <p:nvSpPr>
+          <p:cNvPr id="3" name="Notes Placeholder 2"/>
+          <p:cNvSpPr>
+            <a:spLocks noGrp="1"/>
+          </p:cNvSpPr>
+          <p:nvPr>
+            <p:ph type="body" idx="1"/>
+          </p:nvPr>
+        </p:nvSpPr>
+        <p:spPr/>
+        <p:txBody>
+          <a:bodyPr/>
+          <a:lstStyle/>
+          <a:p>
+            <a:endParaRPr lang="en-US" dirty="0"/>
+          </a:p>
+        </p:txBody>
+      </p:sp>
+      <p:sp>
+        <p:nvSpPr>
+          <p:cNvPr id="4" name="Slide Number Placeholder 3"/>
+          <p:cNvSpPr>
+            <a:spLocks noGrp="1"/>
+          </p:cNvSpPr>
+          <p:nvPr>
+            <p:ph type="sldNum" sz="quarter" idx="10"/>
+          </p:nvPr>
+        </p:nvSpPr>
+        <p:spPr/>
+        <p:txBody>
+          <a:bodyPr/>
+          <a:lstStyle/>
+          <a:p>
+            <a:fld id="{F7021451-1387-4CA6-816F-3879F97B5CBC}" type="slidenum">
+              <a:rPr lang="en-US"/>
+              <a:t>7</a:t>
+            </a:fld>
+            <a:endParaRPr lang="en-US"/>
+          </a:p>
+        </p:txBody>
+      </p:sp>
+    </p:spTree>
+    <p:extLst>
+      <p:ext uri="{BB962C8B-B14F-4D97-AF65-F5344CB8AC3E}">
+        <p14:creationId xmlns:p14="http://schemas.microsoft.com/office/powerpoint/2010/main" val="1024086991"/>
+      </p:ext>
+    </p:extLst>
+  </p:cSld>
+  <p:clrMapOvr>
+    <a:masterClrMapping/>
+  </p:clrMapOvr>
+</p:notes>
+</file>
+
 <file path=ppt/slideLayouts/slideLayout1.xml><?xml version="1.0" encoding="utf-8"?>
 <p:sldLayout xmlns:a="http://schemas.openxmlformats.org/drawingml/2006/main" xmlns:r="http://schemas.openxmlformats.org/officeDocument/2006/relationships" xmlns:p="http://schemas.openxmlformats.org/presentationml/2006/main" preserve="1">
   <p:cSld name="DEFAULT">
@@ -1038,188 +1208,9 @@
           <a:ln/>
         </p:spPr>
       </p:sp>
-      <p:sp>
-        <p:nvSpPr>
-          <p:cNvPr id="5" name="Text 2"/>
-          <p:cNvSpPr/>
-          <p:nvPr/>
-        </p:nvSpPr>
-        <p:spPr>
-          <a:xfrm>
-            <a:off x="777240" y="2148840"/>
-            <a:ext cx="8229600" cy="365760"/>
-          </a:xfrm>
-          <a:prstGeom prst="rect">
-            <a:avLst/>
-          </a:prstGeom>
-          <a:noFill/>
-          <a:ln/>
-        </p:spPr>
-        <p:txBody>
-          <a:bodyPr wrap="square" lIns="0" tIns="0" rIns="0" bIns="0" rtlCol="0" anchor="ctr"/>
-          <a:lstStyle/>
-          <a:p>
-            <a:pPr marL="0" indent="0">
-              <a:buNone/>
-            </a:pPr>
-            <a:r>
-              <a:rPr lang="en-US" sz="1300" kern="0" spc="200" dirty="0">
-                <a:solidFill>
-                  <a:srgbClr val="CCDCEC"/>
-                </a:solidFill>
-                <a:latin typeface="Open Sans" pitchFamily="34" charset="0"/>
-                <a:ea typeface="Open Sans" pitchFamily="34" charset="-122"/>
-                <a:cs typeface="Open Sans" pitchFamily="34" charset="-120"/>
-              </a:rPr>
-              <a:t>SGD · SETDIG   |   DS MS.GOV v2.0.0</a:t>
-            </a:r>
-            <a:endParaRPr lang="en-US" sz="1300" dirty="0"/>
-          </a:p>
-        </p:txBody>
-      </p:sp>
-      <p:sp>
-        <p:nvSpPr>
-          <p:cNvPr id="6" name="Text 3"/>
-          <p:cNvSpPr/>
-          <p:nvPr/>
-        </p:nvSpPr>
-        <p:spPr>
-          <a:xfrm>
-            <a:off x="777240" y="2560320"/>
-            <a:ext cx="8961120" cy="1737360"/>
-          </a:xfrm>
-          <a:prstGeom prst="rect">
-            <a:avLst/>
-          </a:prstGeom>
-          <a:noFill/>
-          <a:ln/>
-        </p:spPr>
-        <p:txBody>
-          <a:bodyPr wrap="square" lIns="0" tIns="0" rIns="0" bIns="0" rtlCol="0" anchor="ctr"/>
-          <a:lstStyle/>
-          <a:p>
-            <a:pPr marL="0" indent="0">
-              <a:lnSpc>
-                <a:spcPct val="100000"/>
-              </a:lnSpc>
-              <a:buNone/>
-            </a:pPr>
-            <a:r>
-              <a:rPr lang="en-US" sz="4600" b="1" dirty="0">
-                <a:solidFill>
-                  <a:srgbClr val="FFFFFF"/>
-                </a:solidFill>
-                <a:latin typeface="Open Sans" pitchFamily="34" charset="0"/>
-                <a:ea typeface="Open Sans" pitchFamily="34" charset="-122"/>
-                <a:cs typeface="Open Sans" pitchFamily="34" charset="-120"/>
-              </a:rPr>
-              <a:t>Design System MS:</a:t>
-            </a:r>
-            <a:endParaRPr lang="en-US" sz="4600" dirty="0"/>
-          </a:p>
-          <a:p>
-            <a:pPr marL="0" indent="0">
-              <a:lnSpc>
-                <a:spcPct val="100000"/>
-              </a:lnSpc>
-              <a:buNone/>
-            </a:pPr>
-            <a:r>
-              <a:rPr lang="en-US" sz="4600" b="1" dirty="0">
-                <a:solidFill>
-                  <a:srgbClr val="FFFFFF"/>
-                </a:solidFill>
-                <a:latin typeface="Open Sans" pitchFamily="34" charset="0"/>
-                <a:ea typeface="Open Sans" pitchFamily="34" charset="-122"/>
-                <a:cs typeface="Open Sans" pitchFamily="34" charset="-120"/>
-              </a:rPr>
-              <a:t>do Figma ao código</a:t>
-            </a:r>
-            <a:endParaRPr lang="en-US" sz="4600" dirty="0"/>
-          </a:p>
-        </p:txBody>
-      </p:sp>
-      <p:sp>
-        <p:nvSpPr>
-          <p:cNvPr id="7" name="Text 4"/>
-          <p:cNvSpPr/>
-          <p:nvPr/>
-        </p:nvSpPr>
-        <p:spPr>
-          <a:xfrm>
-            <a:off x="777240" y="4434840"/>
-            <a:ext cx="8595360" cy="822960"/>
-          </a:xfrm>
-          <a:prstGeom prst="rect">
-            <a:avLst/>
-          </a:prstGeom>
-          <a:noFill/>
-          <a:ln/>
-        </p:spPr>
-        <p:txBody>
-          <a:bodyPr wrap="square" lIns="0" tIns="0" rIns="0" bIns="0" rtlCol="0" anchor="ctr"/>
-          <a:lstStyle/>
-          <a:p>
-            <a:pPr marL="0" indent="0">
-              <a:buNone/>
-            </a:pPr>
-            <a:r>
-              <a:rPr lang="en-US" sz="1900" dirty="0">
-                <a:solidFill>
-                  <a:srgbClr val="CCDCEC"/>
-                </a:solidFill>
-                <a:latin typeface="Open Sans" pitchFamily="34" charset="0"/>
-                <a:ea typeface="Open Sans" pitchFamily="34" charset="-122"/>
-                <a:cs typeface="Open Sans" pitchFamily="34" charset="-120"/>
-              </a:rPr>
-              <a:t>Como escalar a biblioteca de componentes para todos os times do Estado — PHP, Python e JS.</a:t>
-            </a:r>
-            <a:endParaRPr lang="en-US" sz="1900" dirty="0"/>
-          </a:p>
-        </p:txBody>
-      </p:sp>
-      <p:sp>
-        <p:nvSpPr>
-          <p:cNvPr id="8" name="Text 5"/>
-          <p:cNvSpPr/>
-          <p:nvPr/>
-        </p:nvSpPr>
-        <p:spPr>
-          <a:xfrm>
-            <a:off x="777240" y="6126480"/>
-            <a:ext cx="7315200" cy="365760"/>
-          </a:xfrm>
-          <a:prstGeom prst="rect">
-            <a:avLst/>
-          </a:prstGeom>
-          <a:noFill/>
-          <a:ln/>
-        </p:spPr>
-        <p:txBody>
-          <a:bodyPr wrap="square" lIns="0" tIns="0" rIns="0" bIns="0" rtlCol="0" anchor="ctr"/>
-          <a:lstStyle/>
-          <a:p>
-            <a:pPr marL="0" indent="0">
-              <a:buNone/>
-            </a:pPr>
-            <a:r>
-              <a:rPr lang="en-US" sz="1200" dirty="0">
-                <a:solidFill>
-                  <a:srgbClr val="CCDCEC"/>
-                </a:solidFill>
-                <a:latin typeface="Open Sans" pitchFamily="34" charset="0"/>
-                <a:ea typeface="Open Sans" pitchFamily="34" charset="-122"/>
-                <a:cs typeface="Open Sans" pitchFamily="34" charset="-120"/>
-              </a:rPr>
-              <a:t>Fabio Ramos · SETDIG · junho de 2026</a:t>
-            </a:r>
-            <a:endParaRPr lang="en-US" sz="1200" dirty="0"/>
-          </a:p>
-        </p:txBody>
-      </p:sp>
       <p:pic>
         <p:nvPicPr>
-          <p:cNvPr id="9" name="Image 1" descr="C:\Users\Fabio\Documents\SETDIG\2026\projetos\DS-MS Design System\apresentacao\setdig-white.png"/>
+          <p:cNvPr id="4" name="Image 0" descr="C:\Users\Fabio\Documents\SETDIG\2026\projetos\DS-MS Design System\apresentacao\ds-logo-white.png"/>
           <p:cNvPicPr>
             <a:picLocks noChangeAspect="1"/>
           </p:cNvPicPr>
@@ -1233,6 +1224,209 @@
         </p:blipFill>
         <p:spPr>
           <a:xfrm>
+            <a:off x="777240" y="640080"/>
+            <a:ext cx="1828800" cy="518434"/>
+          </a:xfrm>
+          <a:prstGeom prst="rect">
+            <a:avLst/>
+          </a:prstGeom>
+        </p:spPr>
+      </p:pic>
+      <p:sp>
+        <p:nvSpPr>
+          <p:cNvPr id="5" name="Text 2"/>
+          <p:cNvSpPr/>
+          <p:nvPr/>
+        </p:nvSpPr>
+        <p:spPr>
+          <a:xfrm>
+            <a:off x="777240" y="2148840"/>
+            <a:ext cx="8229600" cy="365760"/>
+          </a:xfrm>
+          <a:prstGeom prst="rect">
+            <a:avLst/>
+          </a:prstGeom>
+          <a:noFill/>
+          <a:ln/>
+        </p:spPr>
+        <p:txBody>
+          <a:bodyPr wrap="square" lIns="0" tIns="0" rIns="0" bIns="0" rtlCol="0" anchor="ctr"/>
+          <a:lstStyle/>
+          <a:p>
+            <a:pPr marL="0" indent="0">
+              <a:buNone/>
+            </a:pPr>
+            <a:r>
+              <a:rPr lang="en-US" sz="1300" kern="0" spc="200" dirty="0">
+                <a:solidFill>
+                  <a:srgbClr val="CCDCEC"/>
+                </a:solidFill>
+                <a:latin typeface="Open Sans" pitchFamily="34" charset="0"/>
+                <a:ea typeface="Open Sans" pitchFamily="34" charset="-122"/>
+                <a:cs typeface="Open Sans" pitchFamily="34" charset="-120"/>
+              </a:rPr>
+              <a:t>SGD · SETDIG   |   DS MS.GOV v2.0.0</a:t>
+            </a:r>
+            <a:endParaRPr lang="en-US" sz="1300" dirty="0"/>
+          </a:p>
+        </p:txBody>
+      </p:sp>
+      <p:sp>
+        <p:nvSpPr>
+          <p:cNvPr id="6" name="Text 3"/>
+          <p:cNvSpPr/>
+          <p:nvPr/>
+        </p:nvSpPr>
+        <p:spPr>
+          <a:xfrm>
+            <a:off x="777240" y="2560320"/>
+            <a:ext cx="8961120" cy="1737360"/>
+          </a:xfrm>
+          <a:prstGeom prst="rect">
+            <a:avLst/>
+          </a:prstGeom>
+          <a:noFill/>
+          <a:ln/>
+        </p:spPr>
+        <p:txBody>
+          <a:bodyPr wrap="square" lIns="0" tIns="0" rIns="0" bIns="0" rtlCol="0" anchor="ctr"/>
+          <a:lstStyle/>
+          <a:p>
+            <a:pPr marL="0" indent="0">
+              <a:lnSpc>
+                <a:spcPct val="100000"/>
+              </a:lnSpc>
+              <a:buNone/>
+            </a:pPr>
+            <a:r>
+              <a:rPr lang="en-US" sz="4600" b="1" dirty="0">
+                <a:solidFill>
+                  <a:srgbClr val="FFFFFF"/>
+                </a:solidFill>
+                <a:latin typeface="Open Sans" pitchFamily="34" charset="0"/>
+                <a:ea typeface="Open Sans" pitchFamily="34" charset="-122"/>
+                <a:cs typeface="Open Sans" pitchFamily="34" charset="-120"/>
+              </a:rPr>
+              <a:t>Design System MS:</a:t>
+            </a:r>
+            <a:endParaRPr lang="en-US" sz="4600" dirty="0"/>
+          </a:p>
+          <a:p>
+            <a:pPr marL="0" indent="0">
+              <a:lnSpc>
+                <a:spcPct val="100000"/>
+              </a:lnSpc>
+              <a:buNone/>
+            </a:pPr>
+            <a:r>
+              <a:rPr lang="en-US" sz="4600" b="1" dirty="0">
+                <a:solidFill>
+                  <a:srgbClr val="FFFFFF"/>
+                </a:solidFill>
+                <a:latin typeface="Open Sans" pitchFamily="34" charset="0"/>
+                <a:ea typeface="Open Sans" pitchFamily="34" charset="-122"/>
+                <a:cs typeface="Open Sans" pitchFamily="34" charset="-120"/>
+              </a:rPr>
+              <a:t>do Figma ao código</a:t>
+            </a:r>
+            <a:endParaRPr lang="en-US" sz="4600" dirty="0"/>
+          </a:p>
+        </p:txBody>
+      </p:sp>
+      <p:sp>
+        <p:nvSpPr>
+          <p:cNvPr id="7" name="Text 4"/>
+          <p:cNvSpPr/>
+          <p:nvPr/>
+        </p:nvSpPr>
+        <p:spPr>
+          <a:xfrm>
+            <a:off x="777240" y="4434840"/>
+            <a:ext cx="8595360" cy="822960"/>
+          </a:xfrm>
+          <a:prstGeom prst="rect">
+            <a:avLst/>
+          </a:prstGeom>
+          <a:noFill/>
+          <a:ln/>
+        </p:spPr>
+        <p:txBody>
+          <a:bodyPr wrap="square" lIns="0" tIns="0" rIns="0" bIns="0" rtlCol="0" anchor="ctr"/>
+          <a:lstStyle/>
+          <a:p>
+            <a:pPr marL="0" indent="0">
+              <a:buNone/>
+            </a:pPr>
+            <a:r>
+              <a:rPr lang="en-US" sz="1900" dirty="0">
+                <a:solidFill>
+                  <a:srgbClr val="CCDCEC"/>
+                </a:solidFill>
+                <a:latin typeface="Open Sans" pitchFamily="34" charset="0"/>
+                <a:ea typeface="Open Sans" pitchFamily="34" charset="-122"/>
+                <a:cs typeface="Open Sans" pitchFamily="34" charset="-120"/>
+              </a:rPr>
+              <a:t>Como escalar a biblioteca de componentes para todos os times do Estado — PHP, Python e JS.</a:t>
+            </a:r>
+            <a:endParaRPr lang="en-US" sz="1900" dirty="0"/>
+          </a:p>
+        </p:txBody>
+      </p:sp>
+      <p:sp>
+        <p:nvSpPr>
+          <p:cNvPr id="8" name="Text 5"/>
+          <p:cNvSpPr/>
+          <p:nvPr/>
+        </p:nvSpPr>
+        <p:spPr>
+          <a:xfrm>
+            <a:off x="777240" y="6126480"/>
+            <a:ext cx="8229600" cy="365760"/>
+          </a:xfrm>
+          <a:prstGeom prst="rect">
+            <a:avLst/>
+          </a:prstGeom>
+          <a:noFill/>
+          <a:ln/>
+        </p:spPr>
+        <p:txBody>
+          <a:bodyPr wrap="square" lIns="0" tIns="0" rIns="0" bIns="0" rtlCol="0" anchor="ctr"/>
+          <a:lstStyle/>
+          <a:p>
+            <a:pPr marL="0" indent="0">
+              <a:buNone/>
+            </a:pPr>
+            <a:r>
+              <a:rPr lang="en-US" sz="1200" dirty="0">
+                <a:solidFill>
+                  <a:srgbClr val="CCDCEC"/>
+                </a:solidFill>
+                <a:latin typeface="Open Sans" pitchFamily="34" charset="0"/>
+                <a:ea typeface="Open Sans" pitchFamily="34" charset="-122"/>
+                <a:cs typeface="Open Sans" pitchFamily="34" charset="-120"/>
+              </a:rPr>
+              <a:t>Fabio Ramos · SETDIG · junho de 2026 · pacote já publicado no npm</a:t>
+            </a:r>
+            <a:endParaRPr lang="en-US" sz="1200" dirty="0"/>
+          </a:p>
+        </p:txBody>
+      </p:sp>
+      <p:pic>
+        <p:nvPicPr>
+          <p:cNvPr id="9" name="Image 1" descr="C:\Users\Fabio\Documents\SETDIG\2026\projetos\DS-MS Design System\apresentacao\setdig-white.png"/>
+          <p:cNvPicPr>
+            <a:picLocks noChangeAspect="1"/>
+          </p:cNvPicPr>
+          <p:nvPr/>
+        </p:nvPicPr>
+        <p:blipFill>
+          <a:blip r:embed="rId4"/>
+          <a:stretch>
+            <a:fillRect/>
+          </a:stretch>
+        </p:blipFill>
+        <p:spPr>
+          <a:xfrm>
             <a:off x="10405872" y="5989320"/>
             <a:ext cx="1371600" cy="319571"/>
           </a:xfrm>
@@ -1246,13 +1440,6 @@
   <p:clrMapOvr>
     <a:masterClrMapping/>
   </p:clrMapOvr>
-  <p:timing>
-    <p:tnLst>
-      <p:par>
-        <p:cTn id="1" dur="indefinite" restart="never" nodeType="tmRoot"/>
-      </p:par>
-    </p:tnLst>
-  </p:timing>
 </p:sld>
 </file>
 
@@ -2000,8 +2187,8 @@
         </p:nvSpPr>
         <p:spPr>
           <a:xfrm>
-            <a:off x="11338560" y="6446520"/>
-            <a:ext cx="457200" cy="274320"/>
+            <a:off x="11064240" y="6446520"/>
+            <a:ext cx="731520" cy="274320"/>
           </a:xfrm>
           <a:prstGeom prst="rect">
             <a:avLst/>
@@ -2025,7 +2212,7 @@
                 <a:ea typeface="Open Sans" pitchFamily="34" charset="-122"/>
                 <a:cs typeface="Open Sans" pitchFamily="34" charset="-120"/>
               </a:rPr>
-              <a:t>02</a:t>
+              <a:t>02 / 7</a:t>
             </a:r>
             <a:endParaRPr lang="en-US" sz="900" dirty="0"/>
           </a:p>
@@ -2036,13 +2223,6 @@
   <p:clrMapOvr>
     <a:masterClrMapping/>
   </p:clrMapOvr>
-  <p:timing>
-    <p:tnLst>
-      <p:par>
-        <p:cTn id="1" dur="indefinite" restart="never" nodeType="tmRoot"/>
-      </p:par>
-    </p:tnLst>
-  </p:timing>
 </p:sld>
 </file>
 
@@ -2754,8 +2934,8 @@
         </p:nvSpPr>
         <p:spPr>
           <a:xfrm>
-            <a:off x="11338560" y="6446520"/>
-            <a:ext cx="457200" cy="274320"/>
+            <a:off x="11064240" y="6446520"/>
+            <a:ext cx="731520" cy="274320"/>
           </a:xfrm>
           <a:prstGeom prst="rect">
             <a:avLst/>
@@ -2779,7 +2959,7 @@
                 <a:ea typeface="Open Sans" pitchFamily="34" charset="-122"/>
                 <a:cs typeface="Open Sans" pitchFamily="34" charset="-120"/>
               </a:rPr>
-              <a:t>03</a:t>
+              <a:t>03 / 7</a:t>
             </a:r>
             <a:endParaRPr lang="en-US" sz="900" dirty="0"/>
           </a:p>
@@ -2790,13 +2970,6 @@
   <p:clrMapOvr>
     <a:masterClrMapping/>
   </p:clrMapOvr>
-  <p:timing>
-    <p:tnLst>
-      <p:par>
-        <p:cTn id="1" dur="indefinite" restart="never" nodeType="tmRoot"/>
-      </p:par>
-    </p:tnLst>
-  </p:timing>
 </p:sld>
 </file>
 
@@ -2840,7 +3013,7 @@
             <a:avLst/>
           </a:prstGeom>
           <a:solidFill>
-            <a:srgbClr val="004F9F"/>
+            <a:srgbClr val="DA1E28"/>
           </a:solidFill>
           <a:ln/>
         </p:spPr>
@@ -2872,13 +3045,13 @@
             <a:r>
               <a:rPr lang="en-US" sz="3000" b="1" dirty="0">
                 <a:solidFill>
-                  <a:srgbClr val="004F9F"/>
-                </a:solidFill>
-                <a:latin typeface="Open Sans" pitchFamily="34" charset="0"/>
-                <a:ea typeface="Open Sans" pitchFamily="34" charset="-122"/>
-                <a:cs typeface="Open Sans" pitchFamily="34" charset="-120"/>
-              </a:rPr>
-              <a:t>A solução: uma fonte única que gera código</a:t>
+                  <a:srgbClr val="212A31"/>
+                </a:solidFill>
+                <a:latin typeface="Open Sans" pitchFamily="34" charset="0"/>
+                <a:ea typeface="Open Sans" pitchFamily="34" charset="-122"/>
+                <a:cs typeface="Open Sans" pitchFamily="34" charset="-120"/>
+              </a:rPr>
+              <a:t>Não é teoria: já está acontecendo</a:t>
             </a:r>
             <a:endParaRPr lang="en-US" sz="3000" dirty="0"/>
           </a:p>
@@ -2886,22 +3059,59 @@
       </p:sp>
       <p:sp>
         <p:nvSpPr>
-          <p:cNvPr id="4" name="Shape 2"/>
-          <p:cNvSpPr/>
-          <p:nvPr/>
-        </p:nvSpPr>
-        <p:spPr>
-          <a:xfrm>
-            <a:off x="548640" y="1417320"/>
-            <a:ext cx="2542032" cy="1325880"/>
-          </a:xfrm>
-          <a:prstGeom prst="roundRect">
-            <a:avLst>
-              <a:gd name="adj" fmla="val 5517"/>
-            </a:avLst>
-          </a:prstGeom>
-          <a:solidFill>
-            <a:srgbClr val="F6F8FB"/>
+          <p:cNvPr id="4" name="Text 2"/>
+          <p:cNvSpPr/>
+          <p:nvPr/>
+        </p:nvSpPr>
+        <p:spPr>
+          <a:xfrm>
+            <a:off x="566928" y="1060704"/>
+            <a:ext cx="10789920" cy="365760"/>
+          </a:xfrm>
+          <a:prstGeom prst="rect">
+            <a:avLst/>
+          </a:prstGeom>
+          <a:noFill/>
+          <a:ln/>
+        </p:spPr>
+        <p:txBody>
+          <a:bodyPr wrap="square" lIns="0" tIns="0" rIns="0" bIns="0" rtlCol="0" anchor="ctr"/>
+          <a:lstStyle/>
+          <a:p>
+            <a:pPr marL="0" indent="0">
+              <a:buNone/>
+            </a:pPr>
+            <a:r>
+              <a:rPr lang="en-US" sz="1350" dirty="0">
+                <a:solidFill>
+                  <a:srgbClr val="545D64"/>
+                </a:solidFill>
+                <a:latin typeface="Open Sans" pitchFamily="34" charset="0"/>
+                <a:ea typeface="Open Sans" pitchFamily="34" charset="-122"/>
+                <a:cs typeface="Open Sans" pitchFamily="34" charset="-120"/>
+              </a:rPr>
+              <a:t>Inspeção real (DOM/CSS) do site da SEGOV — outra secretaria do mesmo governo, fora do DS-MS oficial.</a:t>
+            </a:r>
+            <a:endParaRPr lang="en-US" sz="1350" dirty="0"/>
+          </a:p>
+        </p:txBody>
+      </p:sp>
+      <p:sp>
+        <p:nvSpPr>
+          <p:cNvPr id="5" name="Shape 3"/>
+          <p:cNvSpPr/>
+          <p:nvPr/>
+        </p:nvSpPr>
+        <p:spPr>
+          <a:xfrm>
+            <a:off x="521208" y="1554480"/>
+            <a:ext cx="3337560" cy="2120265"/>
+          </a:xfrm>
+          <a:prstGeom prst="rect">
+            <a:avLst/>
+          </a:prstGeom>
+          <a:solidFill>
+            <a:srgbClr val="FFFFFF"/>
           </a:solidFill>
           <a:ln w="12700">
             <a:solidFill>
@@ -2918,71 +3128,56 @@
           </a:effectLst>
         </p:spPr>
       </p:sp>
-      <p:sp>
-        <p:nvSpPr>
-          <p:cNvPr id="5" name="Text 3"/>
-          <p:cNvSpPr/>
-          <p:nvPr/>
-        </p:nvSpPr>
-        <p:spPr>
-          <a:xfrm>
-            <a:off x="658368" y="1673352"/>
-            <a:ext cx="2322576" cy="640080"/>
-          </a:xfrm>
-          <a:prstGeom prst="rect">
-            <a:avLst/>
-          </a:prstGeom>
-          <a:noFill/>
-          <a:ln/>
-        </p:spPr>
-        <p:txBody>
-          <a:bodyPr wrap="square" lIns="0" tIns="0" rIns="0" bIns="0" rtlCol="0" anchor="ctr"/>
-          <a:lstStyle/>
-          <a:p>
-            <a:pPr marL="0" indent="0" algn="ctr">
-              <a:buNone/>
-            </a:pPr>
-            <a:r>
-              <a:rPr lang="en-US" sz="1500" b="1" dirty="0">
-                <a:solidFill>
-                  <a:srgbClr val="004F9F"/>
-                </a:solidFill>
-                <a:latin typeface="Open Sans" pitchFamily="34" charset="0"/>
-                <a:ea typeface="Open Sans" pitchFamily="34" charset="-122"/>
-                <a:cs typeface="Open Sans" pitchFamily="34" charset="-120"/>
-              </a:rPr>
-              <a:t>Figma</a:t>
-            </a:r>
-            <a:endParaRPr lang="en-US" sz="1500" dirty="0"/>
-          </a:p>
-        </p:txBody>
-      </p:sp>
-      <p:sp>
-        <p:nvSpPr>
-          <p:cNvPr id="6" name="Text 4"/>
-          <p:cNvSpPr/>
-          <p:nvPr/>
-        </p:nvSpPr>
-        <p:spPr>
-          <a:xfrm>
-            <a:off x="658368" y="2313432"/>
-            <a:ext cx="2322576" cy="320040"/>
-          </a:xfrm>
-          <a:prstGeom prst="rect">
-            <a:avLst/>
-          </a:prstGeom>
-          <a:noFill/>
-          <a:ln/>
-        </p:spPr>
-        <p:txBody>
-          <a:bodyPr wrap="square" lIns="0" tIns="0" rIns="0" bIns="0" rtlCol="0" anchor="ctr"/>
-          <a:lstStyle/>
-          <a:p>
-            <a:pPr marL="0" indent="0" algn="ctr">
-              <a:buNone/>
-            </a:pPr>
-            <a:r>
-              <a:rPr lang="en-US" sz="1050" dirty="0">
+      <p:pic>
+        <p:nvPicPr>
+          <p:cNvPr id="6" name="Image 0" descr="C:\Users\Fabio\Documents\SETDIG\2026\projetos\DS-MS Design System\docs\assets\segov-codesul\segov-codesul-aberto.png"/>
+          <p:cNvPicPr>
+            <a:picLocks noChangeAspect="1"/>
+          </p:cNvPicPr>
+          <p:nvPr/>
+        </p:nvPicPr>
+        <p:blipFill>
+          <a:blip r:embed="rId3"/>
+          <a:stretch>
+            <a:fillRect/>
+          </a:stretch>
+        </p:blipFill>
+        <p:spPr>
+          <a:xfrm>
+            <a:off x="566928" y="1600200"/>
+            <a:ext cx="3246120" cy="2028825"/>
+          </a:xfrm>
+          <a:prstGeom prst="rect">
+            <a:avLst/>
+          </a:prstGeom>
+        </p:spPr>
+      </p:pic>
+      <p:sp>
+        <p:nvSpPr>
+          <p:cNvPr id="7" name="Text 4"/>
+          <p:cNvSpPr/>
+          <p:nvPr/>
+        </p:nvSpPr>
+        <p:spPr>
+          <a:xfrm>
+            <a:off x="566928" y="3683889"/>
+            <a:ext cx="3246120" cy="274320"/>
+          </a:xfrm>
+          <a:prstGeom prst="rect">
+            <a:avLst/>
+          </a:prstGeom>
+          <a:noFill/>
+          <a:ln/>
+        </p:spPr>
+        <p:txBody>
+          <a:bodyPr wrap="square" lIns="0" tIns="0" rIns="0" bIns="0" rtlCol="0" anchor="ctr"/>
+          <a:lstStyle/>
+          <a:p>
+            <a:pPr marL="0" indent="0">
+              <a:buNone/>
+            </a:pPr>
+            <a:r>
+              <a:rPr lang="en-US" sz="950" i="1" dirty="0">
                 <a:solidFill>
                   <a:srgbClr val="545D64"/>
                 </a:solidFill>
@@ -2990,69 +3185,28 @@
                 <a:ea typeface="Open Sans" pitchFamily="34" charset="-122"/>
                 <a:cs typeface="Open Sans" pitchFamily="34" charset="-120"/>
               </a:rPr>
-              <a:t>Tokens Studio → JSON</a:t>
-            </a:r>
-            <a:endParaRPr lang="en-US" sz="1050" dirty="0"/>
-          </a:p>
-        </p:txBody>
-      </p:sp>
-      <p:sp>
-        <p:nvSpPr>
-          <p:cNvPr id="7" name="Text 5"/>
-          <p:cNvSpPr/>
-          <p:nvPr/>
-        </p:nvSpPr>
-        <p:spPr>
-          <a:xfrm>
-            <a:off x="3090672" y="1417320"/>
-            <a:ext cx="384048" cy="1325880"/>
-          </a:xfrm>
-          <a:prstGeom prst="rect">
-            <a:avLst/>
-          </a:prstGeom>
-          <a:noFill/>
-          <a:ln/>
-        </p:spPr>
-        <p:txBody>
-          <a:bodyPr wrap="square" lIns="0" tIns="0" rIns="0" bIns="0" rtlCol="0" anchor="ctr"/>
-          <a:lstStyle/>
-          <a:p>
-            <a:pPr marL="0" indent="0" algn="ctr">
-              <a:buNone/>
-            </a:pPr>
-            <a:r>
-              <a:rPr lang="en-US" sz="3000" b="1" dirty="0">
-                <a:solidFill>
-                  <a:srgbClr val="004F9F"/>
-                </a:solidFill>
-                <a:latin typeface="Open Sans" pitchFamily="34" charset="0"/>
-                <a:ea typeface="Open Sans" pitchFamily="34" charset="-122"/>
-                <a:cs typeface="Open Sans" pitchFamily="34" charset="-120"/>
-              </a:rPr>
-              <a:t>›</a:t>
-            </a:r>
-            <a:endParaRPr lang="en-US" sz="3000" dirty="0"/>
-          </a:p>
-        </p:txBody>
-      </p:sp>
-      <p:sp>
-        <p:nvSpPr>
-          <p:cNvPr id="8" name="Shape 6"/>
-          <p:cNvSpPr/>
-          <p:nvPr/>
-        </p:nvSpPr>
-        <p:spPr>
-          <a:xfrm>
-            <a:off x="3474720" y="1417320"/>
-            <a:ext cx="2542032" cy="1325880"/>
-          </a:xfrm>
-          <a:prstGeom prst="roundRect">
-            <a:avLst>
-              <a:gd name="adj" fmla="val 5517"/>
-            </a:avLst>
-          </a:prstGeom>
-          <a:solidFill>
-            <a:srgbClr val="F6F8FB"/>
+              <a:t>Acordeão aberto (segov.ms.gov.br)</a:t>
+            </a:r>
+            <a:endParaRPr lang="en-US" sz="950" dirty="0"/>
+          </a:p>
+        </p:txBody>
+      </p:sp>
+      <p:sp>
+        <p:nvSpPr>
+          <p:cNvPr id="8" name="Shape 5"/>
+          <p:cNvSpPr/>
+          <p:nvPr/>
+        </p:nvSpPr>
+        <p:spPr>
+          <a:xfrm>
+            <a:off x="521208" y="3994785"/>
+            <a:ext cx="3337560" cy="2120265"/>
+          </a:xfrm>
+          <a:prstGeom prst="rect">
+            <a:avLst/>
+          </a:prstGeom>
+          <a:solidFill>
+            <a:srgbClr val="FFFFFF"/>
           </a:solidFill>
           <a:ln w="12700">
             <a:solidFill>
@@ -3069,6 +3223,906 @@
           </a:effectLst>
         </p:spPr>
       </p:sp>
+      <p:pic>
+        <p:nvPicPr>
+          <p:cNvPr id="9" name="Image 1" descr="C:\Users\Fabio\Documents\SETDIG\2026\projetos\DS-MS Design System\docs\assets\segov-codesul\segov-dropdown.png"/>
+          <p:cNvPicPr>
+            <a:picLocks noChangeAspect="1"/>
+          </p:cNvPicPr>
+          <p:nvPr/>
+        </p:nvPicPr>
+        <p:blipFill>
+          <a:blip r:embed="rId4"/>
+          <a:stretch>
+            <a:fillRect/>
+          </a:stretch>
+        </p:blipFill>
+        <p:spPr>
+          <a:xfrm>
+            <a:off x="566928" y="4040505"/>
+            <a:ext cx="3246120" cy="2028825"/>
+          </a:xfrm>
+          <a:prstGeom prst="rect">
+            <a:avLst/>
+          </a:prstGeom>
+        </p:spPr>
+      </p:pic>
+      <p:sp>
+        <p:nvSpPr>
+          <p:cNvPr id="10" name="Text 6"/>
+          <p:cNvSpPr/>
+          <p:nvPr/>
+        </p:nvSpPr>
+        <p:spPr>
+          <a:xfrm>
+            <a:off x="566928" y="6124194"/>
+            <a:ext cx="3246120" cy="274320"/>
+          </a:xfrm>
+          <a:prstGeom prst="rect">
+            <a:avLst/>
+          </a:prstGeom>
+          <a:noFill/>
+          <a:ln/>
+        </p:spPr>
+        <p:txBody>
+          <a:bodyPr wrap="square" lIns="0" tIns="0" rIns="0" bIns="0" rtlCol="0" anchor="ctr"/>
+          <a:lstStyle/>
+          <a:p>
+            <a:pPr marL="0" indent="0">
+              <a:buNone/>
+            </a:pPr>
+            <a:r>
+              <a:rPr lang="en-US" sz="950" i="1" dirty="0">
+                <a:solidFill>
+                  <a:srgbClr val="545D64"/>
+                </a:solidFill>
+                <a:latin typeface="Open Sans" pitchFamily="34" charset="0"/>
+                <a:ea typeface="Open Sans" pitchFamily="34" charset="-122"/>
+                <a:cs typeface="Open Sans" pitchFamily="34" charset="-120"/>
+              </a:rPr>
+              <a:t>Mega-menu “Institucional” — padrão sem equivalente no DS-MS</a:t>
+            </a:r>
+            <a:endParaRPr lang="en-US" sz="950" dirty="0"/>
+          </a:p>
+        </p:txBody>
+      </p:sp>
+      <p:sp>
+        <p:nvSpPr>
+          <p:cNvPr id="11" name="Shape 7"/>
+          <p:cNvSpPr/>
+          <p:nvPr/>
+        </p:nvSpPr>
+        <p:spPr>
+          <a:xfrm>
+            <a:off x="4160520" y="1627632"/>
+            <a:ext cx="201168" cy="201168"/>
+          </a:xfrm>
+          <a:prstGeom prst="ellipse">
+            <a:avLst/>
+          </a:prstGeom>
+          <a:solidFill>
+            <a:srgbClr val="198038"/>
+          </a:solidFill>
+          <a:ln/>
+        </p:spPr>
+      </p:sp>
+      <p:sp>
+        <p:nvSpPr>
+          <p:cNvPr id="12" name="Text 8"/>
+          <p:cNvSpPr/>
+          <p:nvPr/>
+        </p:nvSpPr>
+        <p:spPr>
+          <a:xfrm>
+            <a:off x="4480560" y="1545336"/>
+            <a:ext cx="7178040" cy="320040"/>
+          </a:xfrm>
+          <a:prstGeom prst="rect">
+            <a:avLst/>
+          </a:prstGeom>
+          <a:noFill/>
+          <a:ln/>
+        </p:spPr>
+        <p:txBody>
+          <a:bodyPr wrap="square" lIns="0" tIns="0" rIns="0" bIns="0" rtlCol="0" anchor="ctr"/>
+          <a:lstStyle/>
+          <a:p>
+            <a:pPr marL="0" indent="0">
+              <a:buNone/>
+            </a:pPr>
+            <a:r>
+              <a:rPr lang="en-US" sz="1400" b="1" dirty="0">
+                <a:solidFill>
+                  <a:srgbClr val="212A31"/>
+                </a:solidFill>
+                <a:latin typeface="Open Sans" pitchFamily="34" charset="0"/>
+                <a:ea typeface="Open Sans" pitchFamily="34" charset="-122"/>
+                <a:cs typeface="Open Sans" pitchFamily="34" charset="-120"/>
+              </a:rPr>
+              <a:t>Cor certa</a:t>
+            </a:r>
+            <a:endParaRPr lang="en-US" sz="1400" dirty="0"/>
+          </a:p>
+        </p:txBody>
+      </p:sp>
+      <p:sp>
+        <p:nvSpPr>
+          <p:cNvPr id="13" name="Text 9"/>
+          <p:cNvSpPr/>
+          <p:nvPr/>
+        </p:nvSpPr>
+        <p:spPr>
+          <a:xfrm>
+            <a:off x="4480560" y="1874520"/>
+            <a:ext cx="7178040" cy="502920"/>
+          </a:xfrm>
+          <a:prstGeom prst="rect">
+            <a:avLst/>
+          </a:prstGeom>
+          <a:noFill/>
+          <a:ln/>
+        </p:spPr>
+        <p:txBody>
+          <a:bodyPr wrap="square" lIns="0" tIns="0" rIns="0" bIns="0" rtlCol="0" anchor="ctr"/>
+          <a:lstStyle/>
+          <a:p>
+            <a:pPr marL="0" indent="0">
+              <a:buNone/>
+            </a:pPr>
+            <a:r>
+              <a:rPr lang="en-US" sz="1200" dirty="0">
+                <a:solidFill>
+                  <a:srgbClr val="545D64"/>
+                </a:solidFill>
+                <a:latin typeface="Open Sans" pitchFamily="34" charset="0"/>
+                <a:ea typeface="Open Sans" pitchFamily="34" charset="-122"/>
+                <a:cs typeface="Open Sans" pitchFamily="34" charset="-120"/>
+              </a:rPr>
+              <a:t>Faixa e acordeão usam #004F9F — exatamente o nosso token primário.</a:t>
+            </a:r>
+            <a:endParaRPr lang="en-US" sz="1200" dirty="0"/>
+          </a:p>
+        </p:txBody>
+      </p:sp>
+      <p:sp>
+        <p:nvSpPr>
+          <p:cNvPr id="14" name="Shape 10"/>
+          <p:cNvSpPr/>
+          <p:nvPr/>
+        </p:nvSpPr>
+        <p:spPr>
+          <a:xfrm>
+            <a:off x="4160520" y="2542032"/>
+            <a:ext cx="201168" cy="201168"/>
+          </a:xfrm>
+          <a:prstGeom prst="ellipse">
+            <a:avLst/>
+          </a:prstGeom>
+          <a:solidFill>
+            <a:srgbClr val="DA1E28"/>
+          </a:solidFill>
+          <a:ln/>
+        </p:spPr>
+      </p:sp>
+      <p:sp>
+        <p:nvSpPr>
+          <p:cNvPr id="15" name="Text 11"/>
+          <p:cNvSpPr/>
+          <p:nvPr/>
+        </p:nvSpPr>
+        <p:spPr>
+          <a:xfrm>
+            <a:off x="4480560" y="2459736"/>
+            <a:ext cx="7178040" cy="320040"/>
+          </a:xfrm>
+          <a:prstGeom prst="rect">
+            <a:avLst/>
+          </a:prstGeom>
+          <a:noFill/>
+          <a:ln/>
+        </p:spPr>
+        <p:txBody>
+          <a:bodyPr wrap="square" lIns="0" tIns="0" rIns="0" bIns="0" rtlCol="0" anchor="ctr"/>
+          <a:lstStyle/>
+          <a:p>
+            <a:pPr marL="0" indent="0">
+              <a:buNone/>
+            </a:pPr>
+            <a:r>
+              <a:rPr lang="en-US" sz="1400" b="1" dirty="0">
+                <a:solidFill>
+                  <a:srgbClr val="212A31"/>
+                </a:solidFill>
+                <a:latin typeface="Open Sans" pitchFamily="34" charset="0"/>
+                <a:ea typeface="Open Sans" pitchFamily="34" charset="-122"/>
+                <a:cs typeface="Open Sans" pitchFamily="34" charset="-120"/>
+              </a:rPr>
+              <a:t>Falha de teclado</a:t>
+            </a:r>
+            <a:endParaRPr lang="en-US" sz="1400" dirty="0"/>
+          </a:p>
+        </p:txBody>
+      </p:sp>
+      <p:sp>
+        <p:nvSpPr>
+          <p:cNvPr id="16" name="Text 12"/>
+          <p:cNvSpPr/>
+          <p:nvPr/>
+        </p:nvSpPr>
+        <p:spPr>
+          <a:xfrm>
+            <a:off x="4480560" y="2788920"/>
+            <a:ext cx="7178040" cy="502920"/>
+          </a:xfrm>
+          <a:prstGeom prst="rect">
+            <a:avLst/>
+          </a:prstGeom>
+          <a:noFill/>
+          <a:ln/>
+        </p:spPr>
+        <p:txBody>
+          <a:bodyPr wrap="square" lIns="0" tIns="0" rIns="0" bIns="0" rtlCol="0" anchor="ctr"/>
+          <a:lstStyle/>
+          <a:p>
+            <a:pPr marL="0" indent="0">
+              <a:buNone/>
+            </a:pPr>
+            <a:r>
+              <a:rPr lang="en-US" sz="1200" dirty="0">
+                <a:solidFill>
+                  <a:srgbClr val="545D64"/>
+                </a:solidFill>
+                <a:latin typeface="Open Sans" pitchFamily="34" charset="0"/>
+                <a:ea typeface="Open Sans" pitchFamily="34" charset="-122"/>
+                <a:cs typeface="Open Sans" pitchFamily="34" charset="-120"/>
+              </a:rPr>
+              <a:t>Acordeão tem tabIndex="-1": impossível abrir navegando só com Tab.</a:t>
+            </a:r>
+            <a:endParaRPr lang="en-US" sz="1200" dirty="0"/>
+          </a:p>
+        </p:txBody>
+      </p:sp>
+      <p:sp>
+        <p:nvSpPr>
+          <p:cNvPr id="17" name="Shape 13"/>
+          <p:cNvSpPr/>
+          <p:nvPr/>
+        </p:nvSpPr>
+        <p:spPr>
+          <a:xfrm>
+            <a:off x="4160520" y="3456432"/>
+            <a:ext cx="201168" cy="201168"/>
+          </a:xfrm>
+          <a:prstGeom prst="ellipse">
+            <a:avLst/>
+          </a:prstGeom>
+          <a:solidFill>
+            <a:srgbClr val="DA1E28"/>
+          </a:solidFill>
+          <a:ln/>
+        </p:spPr>
+      </p:sp>
+      <p:sp>
+        <p:nvSpPr>
+          <p:cNvPr id="18" name="Text 14"/>
+          <p:cNvSpPr/>
+          <p:nvPr/>
+        </p:nvSpPr>
+        <p:spPr>
+          <a:xfrm>
+            <a:off x="4480560" y="3374136"/>
+            <a:ext cx="7178040" cy="320040"/>
+          </a:xfrm>
+          <a:prstGeom prst="rect">
+            <a:avLst/>
+          </a:prstGeom>
+          <a:noFill/>
+          <a:ln/>
+        </p:spPr>
+        <p:txBody>
+          <a:bodyPr wrap="square" lIns="0" tIns="0" rIns="0" bIns="0" rtlCol="0" anchor="ctr"/>
+          <a:lstStyle/>
+          <a:p>
+            <a:pPr marL="0" indent="0">
+              <a:buNone/>
+            </a:pPr>
+            <a:r>
+              <a:rPr lang="en-US" sz="1400" b="1" dirty="0">
+                <a:solidFill>
+                  <a:srgbClr val="212A31"/>
+                </a:solidFill>
+                <a:latin typeface="Open Sans" pitchFamily="34" charset="0"/>
+                <a:ea typeface="Open Sans" pitchFamily="34" charset="-122"/>
+                <a:cs typeface="Open Sans" pitchFamily="34" charset="-120"/>
+              </a:rPr>
+              <a:t>Falha de leitor de tela</a:t>
+            </a:r>
+            <a:endParaRPr lang="en-US" sz="1400" dirty="0"/>
+          </a:p>
+        </p:txBody>
+      </p:sp>
+      <p:sp>
+        <p:nvSpPr>
+          <p:cNvPr id="19" name="Text 15"/>
+          <p:cNvSpPr/>
+          <p:nvPr/>
+        </p:nvSpPr>
+        <p:spPr>
+          <a:xfrm>
+            <a:off x="4480560" y="3703320"/>
+            <a:ext cx="7178040" cy="502920"/>
+          </a:xfrm>
+          <a:prstGeom prst="rect">
+            <a:avLst/>
+          </a:prstGeom>
+          <a:noFill/>
+          <a:ln/>
+        </p:spPr>
+        <p:txBody>
+          <a:bodyPr wrap="square" lIns="0" tIns="0" rIns="0" bIns="0" rtlCol="0" anchor="ctr"/>
+          <a:lstStyle/>
+          <a:p>
+            <a:pPr marL="0" indent="0">
+              <a:buNone/>
+            </a:pPr>
+            <a:r>
+              <a:rPr lang="en-US" sz="1200" dirty="0">
+                <a:solidFill>
+                  <a:srgbClr val="545D64"/>
+                </a:solidFill>
+                <a:latin typeface="Open Sans" pitchFamily="34" charset="0"/>
+                <a:ea typeface="Open Sans" pitchFamily="34" charset="-122"/>
+                <a:cs typeface="Open Sans" pitchFamily="34" charset="-120"/>
+              </a:rPr>
+              <a:t>Sem role, aria-expanded ou aria-controls — leitor de tela não anuncia nada.</a:t>
+            </a:r>
+            <a:endParaRPr lang="en-US" sz="1200" dirty="0"/>
+          </a:p>
+        </p:txBody>
+      </p:sp>
+      <p:sp>
+        <p:nvSpPr>
+          <p:cNvPr id="20" name="Shape 16"/>
+          <p:cNvSpPr/>
+          <p:nvPr/>
+        </p:nvSpPr>
+        <p:spPr>
+          <a:xfrm>
+            <a:off x="4160520" y="4370832"/>
+            <a:ext cx="201168" cy="201168"/>
+          </a:xfrm>
+          <a:prstGeom prst="ellipse">
+            <a:avLst/>
+          </a:prstGeom>
+          <a:solidFill>
+            <a:srgbClr val="DA1E28"/>
+          </a:solidFill>
+          <a:ln/>
+        </p:spPr>
+      </p:sp>
+      <p:sp>
+        <p:nvSpPr>
+          <p:cNvPr id="21" name="Text 17"/>
+          <p:cNvSpPr/>
+          <p:nvPr/>
+        </p:nvSpPr>
+        <p:spPr>
+          <a:xfrm>
+            <a:off x="4480560" y="4288536"/>
+            <a:ext cx="7178040" cy="320040"/>
+          </a:xfrm>
+          <a:prstGeom prst="rect">
+            <a:avLst/>
+          </a:prstGeom>
+          <a:noFill/>
+          <a:ln/>
+        </p:spPr>
+        <p:txBody>
+          <a:bodyPr wrap="square" lIns="0" tIns="0" rIns="0" bIns="0" rtlCol="0" anchor="ctr"/>
+          <a:lstStyle/>
+          <a:p>
+            <a:pPr marL="0" indent="0">
+              <a:buNone/>
+            </a:pPr>
+            <a:r>
+              <a:rPr lang="en-US" sz="1400" b="1" dirty="0">
+                <a:solidFill>
+                  <a:srgbClr val="212A31"/>
+                </a:solidFill>
+                <a:latin typeface="Open Sans" pitchFamily="34" charset="0"/>
+                <a:ea typeface="Open Sans" pitchFamily="34" charset="-122"/>
+                <a:cs typeface="Open Sans" pitchFamily="34" charset="-120"/>
+              </a:rPr>
+              <a:t>Tipografia divergente</a:t>
+            </a:r>
+            <a:endParaRPr lang="en-US" sz="1400" dirty="0"/>
+          </a:p>
+        </p:txBody>
+      </p:sp>
+      <p:sp>
+        <p:nvSpPr>
+          <p:cNvPr id="22" name="Text 18"/>
+          <p:cNvSpPr/>
+          <p:nvPr/>
+        </p:nvSpPr>
+        <p:spPr>
+          <a:xfrm>
+            <a:off x="4480560" y="4617720"/>
+            <a:ext cx="7178040" cy="502920"/>
+          </a:xfrm>
+          <a:prstGeom prst="rect">
+            <a:avLst/>
+          </a:prstGeom>
+          <a:noFill/>
+          <a:ln/>
+        </p:spPr>
+        <p:txBody>
+          <a:bodyPr wrap="square" lIns="0" tIns="0" rIns="0" bIns="0" rtlCol="0" anchor="ctr"/>
+          <a:lstStyle/>
+          <a:p>
+            <a:pPr marL="0" indent="0">
+              <a:buNone/>
+            </a:pPr>
+            <a:r>
+              <a:rPr lang="en-US" sz="1200" dirty="0">
+                <a:solidFill>
+                  <a:srgbClr val="545D64"/>
+                </a:solidFill>
+                <a:latin typeface="Open Sans" pitchFamily="34" charset="0"/>
+                <a:ea typeface="Open Sans" pitchFamily="34" charset="-122"/>
+                <a:cs typeface="Open Sans" pitchFamily="34" charset="-120"/>
+              </a:rPr>
+              <a:t>Usa a fonte padrão do sistema, não Open Sans/Roboto da marca.</a:t>
+            </a:r>
+            <a:endParaRPr lang="en-US" sz="1200" dirty="0"/>
+          </a:p>
+        </p:txBody>
+      </p:sp>
+      <p:sp>
+        <p:nvSpPr>
+          <p:cNvPr id="23" name="Shape 19"/>
+          <p:cNvSpPr/>
+          <p:nvPr/>
+        </p:nvSpPr>
+        <p:spPr>
+          <a:xfrm>
+            <a:off x="4160520" y="5349240"/>
+            <a:ext cx="7498080" cy="914400"/>
+          </a:xfrm>
+          <a:prstGeom prst="rect">
+            <a:avLst/>
+          </a:prstGeom>
+          <a:solidFill>
+            <a:srgbClr val="F6D3D5"/>
+          </a:solidFill>
+          <a:ln/>
+        </p:spPr>
+      </p:sp>
+      <p:sp>
+        <p:nvSpPr>
+          <p:cNvPr id="24" name="Shape 20"/>
+          <p:cNvSpPr/>
+          <p:nvPr/>
+        </p:nvSpPr>
+        <p:spPr>
+          <a:xfrm>
+            <a:off x="4160520" y="5349240"/>
+            <a:ext cx="91440" cy="914400"/>
+          </a:xfrm>
+          <a:prstGeom prst="rect">
+            <a:avLst/>
+          </a:prstGeom>
+          <a:solidFill>
+            <a:srgbClr val="DA1E28"/>
+          </a:solidFill>
+          <a:ln/>
+        </p:spPr>
+      </p:sp>
+      <p:sp>
+        <p:nvSpPr>
+          <p:cNvPr id="25" name="Text 21"/>
+          <p:cNvSpPr/>
+          <p:nvPr/>
+        </p:nvSpPr>
+        <p:spPr>
+          <a:xfrm>
+            <a:off x="4389120" y="5349240"/>
+            <a:ext cx="7132320" cy="914400"/>
+          </a:xfrm>
+          <a:prstGeom prst="rect">
+            <a:avLst/>
+          </a:prstGeom>
+          <a:noFill/>
+          <a:ln/>
+        </p:spPr>
+        <p:txBody>
+          <a:bodyPr wrap="square" lIns="0" tIns="0" rIns="0" bIns="0" rtlCol="0" anchor="ctr"/>
+          <a:lstStyle/>
+          <a:p>
+            <a:pPr marL="0" indent="0">
+              <a:buNone/>
+            </a:pPr>
+            <a:r>
+              <a:rPr lang="en-US" sz="1250" b="1" dirty="0">
+                <a:solidFill>
+                  <a:srgbClr val="7F161A"/>
+                </a:solidFill>
+                <a:latin typeface="Open Sans" pitchFamily="34" charset="0"/>
+                <a:ea typeface="Open Sans" pitchFamily="34" charset="-122"/>
+                <a:cs typeface="Open Sans" pitchFamily="34" charset="-120"/>
+              </a:rPr>
+              <a:t>Argumento de negócio: </a:t>
+            </a:r>
+            <a:r>
+              <a:rPr lang="en-US" sz="1250" dirty="0">
+                <a:solidFill>
+                  <a:srgbClr val="7F161A"/>
+                </a:solidFill>
+                <a:latin typeface="Open Sans" pitchFamily="34" charset="0"/>
+                <a:ea typeface="Open Sans" pitchFamily="34" charset="-122"/>
+                <a:cs typeface="Open Sans" pitchFamily="34" charset="-120"/>
+              </a:rPr>
+              <a:t>publicar o pacote não é só padronizar visual — é corrigir falhas de acessibilidade reais, hoje, em produção, em outro órgão do mesmo Estado.</a:t>
+            </a:r>
+            <a:endParaRPr lang="en-US" sz="1250" dirty="0"/>
+          </a:p>
+        </p:txBody>
+      </p:sp>
+      <p:sp>
+        <p:nvSpPr>
+          <p:cNvPr id="26" name="Text 22"/>
+          <p:cNvSpPr/>
+          <p:nvPr/>
+        </p:nvSpPr>
+        <p:spPr>
+          <a:xfrm>
+            <a:off x="457200" y="6446520"/>
+            <a:ext cx="8686800" cy="274320"/>
+          </a:xfrm>
+          <a:prstGeom prst="rect">
+            <a:avLst/>
+          </a:prstGeom>
+          <a:noFill/>
+          <a:ln/>
+        </p:spPr>
+        <p:txBody>
+          <a:bodyPr wrap="square" lIns="0" tIns="0" rIns="0" bIns="0" rtlCol="0" anchor="ctr"/>
+          <a:lstStyle/>
+          <a:p>
+            <a:pPr marL="0" indent="0" algn="l">
+              <a:buNone/>
+            </a:pPr>
+            <a:r>
+              <a:rPr lang="en-US" sz="900" dirty="0">
+                <a:solidFill>
+                  <a:srgbClr val="545D64"/>
+                </a:solidFill>
+                <a:latin typeface="Open Sans" pitchFamily="34" charset="0"/>
+                <a:ea typeface="Open Sans" pitchFamily="34" charset="-122"/>
+                <a:cs typeface="Open Sans" pitchFamily="34" charset="-120"/>
+              </a:rPr>
+              <a:t>SETDIG — Secretaria-Executiva de Transformação Digital · Governo de MS</a:t>
+            </a:r>
+            <a:endParaRPr lang="en-US" sz="900" dirty="0"/>
+          </a:p>
+        </p:txBody>
+      </p:sp>
+      <p:sp>
+        <p:nvSpPr>
+          <p:cNvPr id="27" name="Text 23"/>
+          <p:cNvSpPr/>
+          <p:nvPr/>
+        </p:nvSpPr>
+        <p:spPr>
+          <a:xfrm>
+            <a:off x="11064240" y="6446520"/>
+            <a:ext cx="731520" cy="274320"/>
+          </a:xfrm>
+          <a:prstGeom prst="rect">
+            <a:avLst/>
+          </a:prstGeom>
+          <a:noFill/>
+          <a:ln/>
+        </p:spPr>
+        <p:txBody>
+          <a:bodyPr wrap="square" lIns="0" tIns="0" rIns="0" bIns="0" rtlCol="0" anchor="ctr"/>
+          <a:lstStyle/>
+          <a:p>
+            <a:pPr marL="0" indent="0" algn="r">
+              <a:buNone/>
+            </a:pPr>
+            <a:r>
+              <a:rPr lang="en-US" sz="900" dirty="0">
+                <a:solidFill>
+                  <a:srgbClr val="545D64"/>
+                </a:solidFill>
+                <a:latin typeface="Open Sans" pitchFamily="34" charset="0"/>
+                <a:ea typeface="Open Sans" pitchFamily="34" charset="-122"/>
+                <a:cs typeface="Open Sans" pitchFamily="34" charset="-120"/>
+              </a:rPr>
+              <a:t>04 / 7</a:t>
+            </a:r>
+            <a:endParaRPr lang="en-US" sz="900" dirty="0"/>
+          </a:p>
+        </p:txBody>
+      </p:sp>
+    </p:spTree>
+  </p:cSld>
+  <p:clrMapOvr>
+    <a:masterClrMapping/>
+  </p:clrMapOvr>
+</p:sld>
+</file>
+
+<file path=ppt/slides/slide5.xml><?xml version="1.0" encoding="utf-8"?>
+<p:sld xmlns:a="http://schemas.openxmlformats.org/drawingml/2006/main" xmlns:r="http://schemas.openxmlformats.org/officeDocument/2006/relationships" xmlns:p="http://schemas.openxmlformats.org/presentationml/2006/main">
+  <p:cSld name="Slide 5">
+    <p:bg>
+      <p:bgPr>
+        <a:solidFill>
+          <a:srgbClr val="FFFFFF"/>
+        </a:solidFill>
+        <a:effectLst/>
+      </p:bgPr>
+    </p:bg>
+    <p:spTree>
+      <p:nvGrpSpPr>
+        <p:cNvPr id="1" name=""/>
+        <p:cNvGrpSpPr/>
+        <p:nvPr/>
+      </p:nvGrpSpPr>
+      <p:grpSpPr>
+        <a:xfrm>
+          <a:off x="0" y="0"/>
+          <a:ext cx="0" cy="0"/>
+          <a:chOff x="0" y="0"/>
+          <a:chExt cx="0" cy="0"/>
+        </a:xfrm>
+      </p:grpSpPr>
+      <p:sp>
+        <p:nvSpPr>
+          <p:cNvPr id="2" name="Shape 0"/>
+          <p:cNvSpPr/>
+          <p:nvPr/>
+        </p:nvSpPr>
+        <p:spPr>
+          <a:xfrm>
+            <a:off x="0" y="0"/>
+            <a:ext cx="146304" cy="6858000"/>
+          </a:xfrm>
+          <a:prstGeom prst="rect">
+            <a:avLst/>
+          </a:prstGeom>
+          <a:solidFill>
+            <a:srgbClr val="004F9F"/>
+          </a:solidFill>
+          <a:ln/>
+        </p:spPr>
+      </p:sp>
+      <p:sp>
+        <p:nvSpPr>
+          <p:cNvPr id="3" name="Text 1"/>
+          <p:cNvSpPr/>
+          <p:nvPr/>
+        </p:nvSpPr>
+        <p:spPr>
+          <a:xfrm>
+            <a:off x="548640" y="411480"/>
+            <a:ext cx="11247120" cy="640080"/>
+          </a:xfrm>
+          <a:prstGeom prst="rect">
+            <a:avLst/>
+          </a:prstGeom>
+          <a:noFill/>
+          <a:ln/>
+        </p:spPr>
+        <p:txBody>
+          <a:bodyPr wrap="square" lIns="0" tIns="0" rIns="0" bIns="0" rtlCol="0" anchor="ctr"/>
+          <a:lstStyle/>
+          <a:p>
+            <a:pPr marL="0" indent="0">
+              <a:buNone/>
+            </a:pPr>
+            <a:r>
+              <a:rPr lang="en-US" sz="3000" b="1" dirty="0">
+                <a:solidFill>
+                  <a:srgbClr val="004F9F"/>
+                </a:solidFill>
+                <a:latin typeface="Open Sans" pitchFamily="34" charset="0"/>
+                <a:ea typeface="Open Sans" pitchFamily="34" charset="-122"/>
+                <a:cs typeface="Open Sans" pitchFamily="34" charset="-120"/>
+              </a:rPr>
+              <a:t>A solução: uma fonte única que gera código</a:t>
+            </a:r>
+            <a:endParaRPr lang="en-US" sz="3000" dirty="0"/>
+          </a:p>
+        </p:txBody>
+      </p:sp>
+      <p:sp>
+        <p:nvSpPr>
+          <p:cNvPr id="4" name="Shape 2"/>
+          <p:cNvSpPr/>
+          <p:nvPr/>
+        </p:nvSpPr>
+        <p:spPr>
+          <a:xfrm>
+            <a:off x="548640" y="1417320"/>
+            <a:ext cx="2542032" cy="1325880"/>
+          </a:xfrm>
+          <a:prstGeom prst="roundRect">
+            <a:avLst>
+              <a:gd name="adj" fmla="val 5517"/>
+            </a:avLst>
+          </a:prstGeom>
+          <a:solidFill>
+            <a:srgbClr val="F6F8FB"/>
+          </a:solidFill>
+          <a:ln w="12700">
+            <a:solidFill>
+              <a:srgbClr val="D4D7D8"/>
+            </a:solidFill>
+            <a:prstDash val="solid"/>
+          </a:ln>
+          <a:effectLst>
+            <a:outerShdw blurRad="88900" dist="38100" dir="8100000" algn="bl" rotWithShape="0">
+              <a:srgbClr val="000000">
+                <a:alpha val="18000"/>
+              </a:srgbClr>
+            </a:outerShdw>
+          </a:effectLst>
+        </p:spPr>
+      </p:sp>
+      <p:sp>
+        <p:nvSpPr>
+          <p:cNvPr id="5" name="Text 3"/>
+          <p:cNvSpPr/>
+          <p:nvPr/>
+        </p:nvSpPr>
+        <p:spPr>
+          <a:xfrm>
+            <a:off x="658368" y="1673352"/>
+            <a:ext cx="2322576" cy="640080"/>
+          </a:xfrm>
+          <a:prstGeom prst="rect">
+            <a:avLst/>
+          </a:prstGeom>
+          <a:noFill/>
+          <a:ln/>
+        </p:spPr>
+        <p:txBody>
+          <a:bodyPr wrap="square" lIns="0" tIns="0" rIns="0" bIns="0" rtlCol="0" anchor="ctr"/>
+          <a:lstStyle/>
+          <a:p>
+            <a:pPr marL="0" indent="0" algn="ctr">
+              <a:buNone/>
+            </a:pPr>
+            <a:r>
+              <a:rPr lang="en-US" sz="1500" b="1" dirty="0">
+                <a:solidFill>
+                  <a:srgbClr val="004F9F"/>
+                </a:solidFill>
+                <a:latin typeface="Open Sans" pitchFamily="34" charset="0"/>
+                <a:ea typeface="Open Sans" pitchFamily="34" charset="-122"/>
+                <a:cs typeface="Open Sans" pitchFamily="34" charset="-120"/>
+              </a:rPr>
+              <a:t>Figma</a:t>
+            </a:r>
+            <a:endParaRPr lang="en-US" sz="1500" dirty="0"/>
+          </a:p>
+        </p:txBody>
+      </p:sp>
+      <p:sp>
+        <p:nvSpPr>
+          <p:cNvPr id="6" name="Text 4"/>
+          <p:cNvSpPr/>
+          <p:nvPr/>
+        </p:nvSpPr>
+        <p:spPr>
+          <a:xfrm>
+            <a:off x="658368" y="2313432"/>
+            <a:ext cx="2322576" cy="320040"/>
+          </a:xfrm>
+          <a:prstGeom prst="rect">
+            <a:avLst/>
+          </a:prstGeom>
+          <a:noFill/>
+          <a:ln/>
+        </p:spPr>
+        <p:txBody>
+          <a:bodyPr wrap="square" lIns="0" tIns="0" rIns="0" bIns="0" rtlCol="0" anchor="ctr"/>
+          <a:lstStyle/>
+          <a:p>
+            <a:pPr marL="0" indent="0" algn="ctr">
+              <a:buNone/>
+            </a:pPr>
+            <a:r>
+              <a:rPr lang="en-US" sz="1050" dirty="0">
+                <a:solidFill>
+                  <a:srgbClr val="545D64"/>
+                </a:solidFill>
+                <a:latin typeface="Open Sans" pitchFamily="34" charset="0"/>
+                <a:ea typeface="Open Sans" pitchFamily="34" charset="-122"/>
+                <a:cs typeface="Open Sans" pitchFamily="34" charset="-120"/>
+              </a:rPr>
+              <a:t>Tokens Studio → JSON</a:t>
+            </a:r>
+            <a:endParaRPr lang="en-US" sz="1050" dirty="0"/>
+          </a:p>
+        </p:txBody>
+      </p:sp>
+      <p:sp>
+        <p:nvSpPr>
+          <p:cNvPr id="7" name="Text 5"/>
+          <p:cNvSpPr/>
+          <p:nvPr/>
+        </p:nvSpPr>
+        <p:spPr>
+          <a:xfrm>
+            <a:off x="3090672" y="1417320"/>
+            <a:ext cx="384048" cy="1325880"/>
+          </a:xfrm>
+          <a:prstGeom prst="rect">
+            <a:avLst/>
+          </a:prstGeom>
+          <a:noFill/>
+          <a:ln/>
+        </p:spPr>
+        <p:txBody>
+          <a:bodyPr wrap="square" lIns="0" tIns="0" rIns="0" bIns="0" rtlCol="0" anchor="ctr"/>
+          <a:lstStyle/>
+          <a:p>
+            <a:pPr marL="0" indent="0" algn="ctr">
+              <a:buNone/>
+            </a:pPr>
+            <a:r>
+              <a:rPr lang="en-US" sz="3000" b="1" dirty="0">
+                <a:solidFill>
+                  <a:srgbClr val="004F9F"/>
+                </a:solidFill>
+                <a:latin typeface="Open Sans" pitchFamily="34" charset="0"/>
+                <a:ea typeface="Open Sans" pitchFamily="34" charset="-122"/>
+                <a:cs typeface="Open Sans" pitchFamily="34" charset="-120"/>
+              </a:rPr>
+              <a:t>›</a:t>
+            </a:r>
+            <a:endParaRPr lang="en-US" sz="3000" dirty="0"/>
+          </a:p>
+        </p:txBody>
+      </p:sp>
+      <p:sp>
+        <p:nvSpPr>
+          <p:cNvPr id="8" name="Shape 6"/>
+          <p:cNvSpPr/>
+          <p:nvPr/>
+        </p:nvSpPr>
+        <p:spPr>
+          <a:xfrm>
+            <a:off x="3474720" y="1417320"/>
+            <a:ext cx="2542032" cy="1325880"/>
+          </a:xfrm>
+          <a:prstGeom prst="roundRect">
+            <a:avLst>
+              <a:gd name="adj" fmla="val 5517"/>
+            </a:avLst>
+          </a:prstGeom>
+          <a:solidFill>
+            <a:srgbClr val="F6F8FB"/>
+          </a:solidFill>
+          <a:ln w="12700">
+            <a:solidFill>
+              <a:srgbClr val="D4D7D8"/>
+            </a:solidFill>
+            <a:prstDash val="solid"/>
+          </a:ln>
+          <a:effectLst>
+            <a:outerShdw blurRad="88900" dist="38100" dir="8100000" algn="bl" rotWithShape="0">
+              <a:srgbClr val="000000">
+                <a:alpha val="18000"/>
+              </a:srgbClr>
+            </a:outerShdw>
+          </a:effectLst>
+        </p:spPr>
+      </p:sp>
       <p:sp>
         <p:nvSpPr>
           <p:cNvPr id="9" name="Text 7"/>
@@ -3908,7 +4962,7 @@
                 <a:ea typeface="Open Sans" pitchFamily="34" charset="-122"/>
                 <a:cs typeface="Open Sans" pitchFamily="34" charset="-120"/>
               </a:rPr>
-              <a:t>POC já funciona: </a:t>
+              <a:t>Já não é só prova de conceito: </a:t>
             </a:r>
             <a:r>
               <a:rPr lang="en-US" sz="1350" dirty="0">
@@ -3919,7 +4973,7 @@
                 <a:ea typeface="Open Sans" pitchFamily="34" charset="-122"/>
                 <a:cs typeface="Open Sans" pitchFamily="34" charset="-120"/>
               </a:rPr>
-              <a:t>o token #004F9F foi gerado em 5 linguagens (CSS/SCSS/JS/PHP/Python) e o Storybook compilou com sucesso.</a:t>
+              <a:t>10 componentes implementados, Web Component próprio e o pacote já publicado de verdade (próximo slide).</a:t>
             </a:r>
             <a:endParaRPr lang="en-US" sz="1350" dirty="0"/>
           </a:p>
@@ -3972,8 +5026,8 @@
         </p:nvSpPr>
         <p:spPr>
           <a:xfrm>
-            <a:off x="11338560" y="6446520"/>
-            <a:ext cx="457200" cy="274320"/>
+            <a:off x="11064240" y="6446520"/>
+            <a:ext cx="731520" cy="274320"/>
           </a:xfrm>
           <a:prstGeom prst="rect">
             <a:avLst/>
@@ -3997,7 +5051,7 @@
                 <a:ea typeface="Open Sans" pitchFamily="34" charset="-122"/>
                 <a:cs typeface="Open Sans" pitchFamily="34" charset="-120"/>
               </a:rPr>
-              <a:t>04</a:t>
+              <a:t>05 / 7</a:t>
             </a:r>
             <a:endParaRPr lang="en-US" sz="900" dirty="0"/>
           </a:p>
@@ -4008,19 +5062,12 @@
   <p:clrMapOvr>
     <a:masterClrMapping/>
   </p:clrMapOvr>
-  <p:timing>
-    <p:tnLst>
-      <p:par>
-        <p:cTn id="1" dur="indefinite" restart="never" nodeType="tmRoot"/>
-      </p:par>
-    </p:tnLst>
-  </p:timing>
 </p:sld>
 </file>
 
-<file path=ppt/slides/slide5.xml><?xml version="1.0" encoding="utf-8"?>
+<file path=ppt/slides/slide6.xml><?xml version="1.0" encoding="utf-8"?>
 <p:sld xmlns:a="http://schemas.openxmlformats.org/drawingml/2006/main" xmlns:r="http://schemas.openxmlformats.org/officeDocument/2006/relationships" xmlns:p="http://schemas.openxmlformats.org/presentationml/2006/main">
-  <p:cSld name="Slide 5">
+  <p:cSld name="Slide 6">
     <p:bg>
       <p:bgPr>
         <a:solidFill>
@@ -4096,6 +5143,980 @@
                 <a:ea typeface="Open Sans" pitchFamily="34" charset="-122"/>
                 <a:cs typeface="Open Sans" pitchFamily="34" charset="-120"/>
               </a:rPr>
+              <a:t>Já está no ar</a:t>
+            </a:r>
+            <a:endParaRPr lang="en-US" sz="3400" dirty="0"/>
+          </a:p>
+        </p:txBody>
+      </p:sp>
+      <p:sp>
+        <p:nvSpPr>
+          <p:cNvPr id="4" name="Text 2"/>
+          <p:cNvSpPr/>
+          <p:nvPr/>
+        </p:nvSpPr>
+        <p:spPr>
+          <a:xfrm>
+            <a:off x="566928" y="1143000"/>
+            <a:ext cx="10058400" cy="365760"/>
+          </a:xfrm>
+          <a:prstGeom prst="rect">
+            <a:avLst/>
+          </a:prstGeom>
+          <a:noFill/>
+          <a:ln/>
+        </p:spPr>
+        <p:txBody>
+          <a:bodyPr wrap="square" lIns="0" tIns="0" rIns="0" bIns="0" rtlCol="0" anchor="ctr"/>
+          <a:lstStyle/>
+          <a:p>
+            <a:pPr marL="0" indent="0">
+              <a:buNone/>
+            </a:pPr>
+            <a:r>
+              <a:rPr lang="en-US" sz="1400" dirty="0">
+                <a:solidFill>
+                  <a:srgbClr val="CCDCEC"/>
+                </a:solidFill>
+                <a:latin typeface="Open Sans" pitchFamily="34" charset="0"/>
+                <a:ea typeface="Open Sans" pitchFamily="34" charset="-122"/>
+                <a:cs typeface="Open Sans" pitchFamily="34" charset="-120"/>
+              </a:rPr>
+              <a:t>Publicado e funcionando — não é mockup, é o link real.</a:t>
+            </a:r>
+            <a:endParaRPr lang="en-US" sz="1400" dirty="0"/>
+          </a:p>
+        </p:txBody>
+      </p:sp>
+      <p:sp>
+        <p:nvSpPr>
+          <p:cNvPr id="5" name="Shape 3"/>
+          <p:cNvSpPr/>
+          <p:nvPr/>
+        </p:nvSpPr>
+        <p:spPr>
+          <a:xfrm>
+            <a:off x="548640" y="1691640"/>
+            <a:ext cx="3520440" cy="1143000"/>
+          </a:xfrm>
+          <a:prstGeom prst="rect">
+            <a:avLst/>
+          </a:prstGeom>
+          <a:solidFill>
+            <a:srgbClr val="002F5F"/>
+          </a:solidFill>
+          <a:ln/>
+        </p:spPr>
+      </p:sp>
+      <p:sp>
+        <p:nvSpPr>
+          <p:cNvPr id="6" name="Text 4"/>
+          <p:cNvSpPr/>
+          <p:nvPr/>
+        </p:nvSpPr>
+        <p:spPr>
+          <a:xfrm>
+            <a:off x="731520" y="1801368"/>
+            <a:ext cx="3154680" cy="548640"/>
+          </a:xfrm>
+          <a:prstGeom prst="rect">
+            <a:avLst/>
+          </a:prstGeom>
+          <a:noFill/>
+          <a:ln/>
+        </p:spPr>
+        <p:txBody>
+          <a:bodyPr wrap="square" lIns="0" tIns="0" rIns="0" bIns="0" rtlCol="0" anchor="ctr"/>
+          <a:lstStyle/>
+          <a:p>
+            <a:pPr marL="0" indent="0">
+              <a:buNone/>
+            </a:pPr>
+            <a:r>
+              <a:rPr lang="en-US" sz="2600" b="1" dirty="0">
+                <a:solidFill>
+                  <a:srgbClr val="FFFFFF"/>
+                </a:solidFill>
+                <a:latin typeface="Open Sans" pitchFamily="34" charset="0"/>
+                <a:ea typeface="Open Sans" pitchFamily="34" charset="-122"/>
+                <a:cs typeface="Open Sans" pitchFamily="34" charset="-120"/>
+              </a:rPr>
+              <a:t>10 / 41</a:t>
+            </a:r>
+            <a:endParaRPr lang="en-US" sz="2600" dirty="0"/>
+          </a:p>
+        </p:txBody>
+      </p:sp>
+      <p:sp>
+        <p:nvSpPr>
+          <p:cNvPr id="7" name="Text 5"/>
+          <p:cNvSpPr/>
+          <p:nvPr/>
+        </p:nvSpPr>
+        <p:spPr>
+          <a:xfrm>
+            <a:off x="731520" y="2377440"/>
+            <a:ext cx="3154680" cy="365760"/>
+          </a:xfrm>
+          <a:prstGeom prst="rect">
+            <a:avLst/>
+          </a:prstGeom>
+          <a:noFill/>
+          <a:ln/>
+        </p:spPr>
+        <p:txBody>
+          <a:bodyPr wrap="square" lIns="0" tIns="0" rIns="0" bIns="0" rtlCol="0" anchor="ctr"/>
+          <a:lstStyle/>
+          <a:p>
+            <a:pPr marL="0" indent="0">
+              <a:buNone/>
+            </a:pPr>
+            <a:r>
+              <a:rPr lang="en-US" sz="1150" dirty="0">
+                <a:solidFill>
+                  <a:srgbClr val="CCDCEC"/>
+                </a:solidFill>
+                <a:latin typeface="Open Sans" pitchFamily="34" charset="0"/>
+                <a:ea typeface="Open Sans" pitchFamily="34" charset="-122"/>
+                <a:cs typeface="Open Sans" pitchFamily="34" charset="-120"/>
+              </a:rPr>
+              <a:t>componentes já no pacote</a:t>
+            </a:r>
+            <a:endParaRPr lang="en-US" sz="1150" dirty="0"/>
+          </a:p>
+        </p:txBody>
+      </p:sp>
+      <p:sp>
+        <p:nvSpPr>
+          <p:cNvPr id="8" name="Shape 6"/>
+          <p:cNvSpPr/>
+          <p:nvPr/>
+        </p:nvSpPr>
+        <p:spPr>
+          <a:xfrm>
+            <a:off x="4297680" y="1691640"/>
+            <a:ext cx="3520440" cy="1143000"/>
+          </a:xfrm>
+          <a:prstGeom prst="rect">
+            <a:avLst/>
+          </a:prstGeom>
+          <a:solidFill>
+            <a:srgbClr val="002F5F"/>
+          </a:solidFill>
+          <a:ln/>
+        </p:spPr>
+      </p:sp>
+      <p:sp>
+        <p:nvSpPr>
+          <p:cNvPr id="9" name="Text 7"/>
+          <p:cNvSpPr/>
+          <p:nvPr/>
+        </p:nvSpPr>
+        <p:spPr>
+          <a:xfrm>
+            <a:off x="4480560" y="1801368"/>
+            <a:ext cx="3154680" cy="548640"/>
+          </a:xfrm>
+          <a:prstGeom prst="rect">
+            <a:avLst/>
+          </a:prstGeom>
+          <a:noFill/>
+          <a:ln/>
+        </p:spPr>
+        <p:txBody>
+          <a:bodyPr wrap="square" lIns="0" tIns="0" rIns="0" bIns="0" rtlCol="0" anchor="ctr"/>
+          <a:lstStyle/>
+          <a:p>
+            <a:pPr marL="0" indent="0">
+              <a:buNone/>
+            </a:pPr>
+            <a:r>
+              <a:rPr lang="en-US" sz="2600" b="1" dirty="0">
+                <a:solidFill>
+                  <a:srgbClr val="FFFFFF"/>
+                </a:solidFill>
+                <a:latin typeface="Open Sans" pitchFamily="34" charset="0"/>
+                <a:ea typeface="Open Sans" pitchFamily="34" charset="-122"/>
+                <a:cs typeface="Open Sans" pitchFamily="34" charset="-120"/>
+              </a:rPr>
+              <a:t>R$ 0/mês</a:t>
+            </a:r>
+            <a:endParaRPr lang="en-US" sz="2600" dirty="0"/>
+          </a:p>
+        </p:txBody>
+      </p:sp>
+      <p:sp>
+        <p:nvSpPr>
+          <p:cNvPr id="10" name="Text 8"/>
+          <p:cNvSpPr/>
+          <p:nvPr/>
+        </p:nvSpPr>
+        <p:spPr>
+          <a:xfrm>
+            <a:off x="4480560" y="2377440"/>
+            <a:ext cx="3154680" cy="365760"/>
+          </a:xfrm>
+          <a:prstGeom prst="rect">
+            <a:avLst/>
+          </a:prstGeom>
+          <a:noFill/>
+          <a:ln/>
+        </p:spPr>
+        <p:txBody>
+          <a:bodyPr wrap="square" lIns="0" tIns="0" rIns="0" bIns="0" rtlCol="0" anchor="ctr"/>
+          <a:lstStyle/>
+          <a:p>
+            <a:pPr marL="0" indent="0">
+              <a:buNone/>
+            </a:pPr>
+            <a:r>
+              <a:rPr lang="en-US" sz="1150" dirty="0">
+                <a:solidFill>
+                  <a:srgbClr val="CCDCEC"/>
+                </a:solidFill>
+                <a:latin typeface="Open Sans" pitchFamily="34" charset="0"/>
+                <a:ea typeface="Open Sans" pitchFamily="34" charset="-122"/>
+                <a:cs typeface="Open Sans" pitchFamily="34" charset="-120"/>
+              </a:rPr>
+              <a:t>custo de infraestrutura</a:t>
+            </a:r>
+            <a:endParaRPr lang="en-US" sz="1150" dirty="0"/>
+          </a:p>
+        </p:txBody>
+      </p:sp>
+      <p:sp>
+        <p:nvSpPr>
+          <p:cNvPr id="11" name="Shape 9"/>
+          <p:cNvSpPr/>
+          <p:nvPr/>
+        </p:nvSpPr>
+        <p:spPr>
+          <a:xfrm>
+            <a:off x="8046720" y="1691640"/>
+            <a:ext cx="3520440" cy="1143000"/>
+          </a:xfrm>
+          <a:prstGeom prst="rect">
+            <a:avLst/>
+          </a:prstGeom>
+          <a:solidFill>
+            <a:srgbClr val="002F5F"/>
+          </a:solidFill>
+          <a:ln/>
+        </p:spPr>
+      </p:sp>
+      <p:sp>
+        <p:nvSpPr>
+          <p:cNvPr id="12" name="Text 10"/>
+          <p:cNvSpPr/>
+          <p:nvPr/>
+        </p:nvSpPr>
+        <p:spPr>
+          <a:xfrm>
+            <a:off x="8229600" y="1801368"/>
+            <a:ext cx="3154680" cy="548640"/>
+          </a:xfrm>
+          <a:prstGeom prst="rect">
+            <a:avLst/>
+          </a:prstGeom>
+          <a:noFill/>
+          <a:ln/>
+        </p:spPr>
+        <p:txBody>
+          <a:bodyPr wrap="square" lIns="0" tIns="0" rIns="0" bIns="0" rtlCol="0" anchor="ctr"/>
+          <a:lstStyle/>
+          <a:p>
+            <a:pPr marL="0" indent="0">
+              <a:buNone/>
+            </a:pPr>
+            <a:r>
+              <a:rPr lang="en-US" sz="2600" b="1" dirty="0">
+                <a:solidFill>
+                  <a:srgbClr val="FFFFFF"/>
+                </a:solidFill>
+                <a:latin typeface="Open Sans" pitchFamily="34" charset="0"/>
+                <a:ea typeface="Open Sans" pitchFamily="34" charset="-122"/>
+                <a:cs typeface="Open Sans" pitchFamily="34" charset="-120"/>
+              </a:rPr>
+              <a:t>0.1.0</a:t>
+            </a:r>
+            <a:endParaRPr lang="en-US" sz="2600" dirty="0"/>
+          </a:p>
+        </p:txBody>
+      </p:sp>
+      <p:sp>
+        <p:nvSpPr>
+          <p:cNvPr id="13" name="Text 11"/>
+          <p:cNvSpPr/>
+          <p:nvPr/>
+        </p:nvSpPr>
+        <p:spPr>
+          <a:xfrm>
+            <a:off x="8229600" y="2377440"/>
+            <a:ext cx="3154680" cy="365760"/>
+          </a:xfrm>
+          <a:prstGeom prst="rect">
+            <a:avLst/>
+          </a:prstGeom>
+          <a:noFill/>
+          <a:ln/>
+        </p:spPr>
+        <p:txBody>
+          <a:bodyPr wrap="square" lIns="0" tIns="0" rIns="0" bIns="0" rtlCol="0" anchor="ctr"/>
+          <a:lstStyle/>
+          <a:p>
+            <a:pPr marL="0" indent="0">
+              <a:buNone/>
+            </a:pPr>
+            <a:r>
+              <a:rPr lang="en-US" sz="1150" dirty="0">
+                <a:solidFill>
+                  <a:srgbClr val="CCDCEC"/>
+                </a:solidFill>
+                <a:latin typeface="Open Sans" pitchFamily="34" charset="0"/>
+                <a:ea typeface="Open Sans" pitchFamily="34" charset="-122"/>
+                <a:cs typeface="Open Sans" pitchFamily="34" charset="-120"/>
+              </a:rPr>
+              <a:t>primeira versão publicada</a:t>
+            </a:r>
+            <a:endParaRPr lang="en-US" sz="1150" dirty="0"/>
+          </a:p>
+        </p:txBody>
+      </p:sp>
+      <p:sp>
+        <p:nvSpPr>
+          <p:cNvPr id="14" name="Shape 12"/>
+          <p:cNvSpPr/>
+          <p:nvPr/>
+        </p:nvSpPr>
+        <p:spPr>
+          <a:xfrm>
+            <a:off x="548640" y="3108960"/>
+            <a:ext cx="11091672" cy="868680"/>
+          </a:xfrm>
+          <a:prstGeom prst="rect">
+            <a:avLst/>
+          </a:prstGeom>
+          <a:solidFill>
+            <a:srgbClr val="FFFFFF"/>
+          </a:solidFill>
+          <a:ln/>
+        </p:spPr>
+      </p:sp>
+      <p:sp>
+        <p:nvSpPr>
+          <p:cNvPr id="15" name="Shape 13"/>
+          <p:cNvSpPr/>
+          <p:nvPr/>
+        </p:nvSpPr>
+        <p:spPr>
+          <a:xfrm>
+            <a:off x="548640" y="3108960"/>
+            <a:ext cx="91440" cy="868680"/>
+          </a:xfrm>
+          <a:prstGeom prst="rect">
+            <a:avLst/>
+          </a:prstGeom>
+          <a:solidFill>
+            <a:srgbClr val="198038"/>
+          </a:solidFill>
+          <a:ln/>
+        </p:spPr>
+      </p:sp>
+      <p:sp>
+        <p:nvSpPr>
+          <p:cNvPr id="16" name="Text 14"/>
+          <p:cNvSpPr/>
+          <p:nvPr/>
+        </p:nvSpPr>
+        <p:spPr>
+          <a:xfrm>
+            <a:off x="822960" y="3218688"/>
+            <a:ext cx="2926080" cy="365760"/>
+          </a:xfrm>
+          <a:prstGeom prst="rect">
+            <a:avLst/>
+          </a:prstGeom>
+          <a:noFill/>
+          <a:ln/>
+        </p:spPr>
+        <p:txBody>
+          <a:bodyPr wrap="square" lIns="0" tIns="0" rIns="0" bIns="0" rtlCol="0" anchor="ctr"/>
+          <a:lstStyle/>
+          <a:p>
+            <a:pPr marL="0" indent="0">
+              <a:buNone/>
+            </a:pPr>
+            <a:r>
+              <a:rPr lang="en-US" sz="1400" b="1" dirty="0">
+                <a:solidFill>
+                  <a:srgbClr val="004F9F"/>
+                </a:solidFill>
+                <a:latin typeface="Open Sans" pitchFamily="34" charset="0"/>
+                <a:ea typeface="Open Sans" pitchFamily="34" charset="-122"/>
+                <a:cs typeface="Open Sans" pitchFamily="34" charset="-120"/>
+              </a:rPr>
+              <a:t>Pacote npm</a:t>
+            </a:r>
+            <a:endParaRPr lang="en-US" sz="1400" dirty="0"/>
+          </a:p>
+        </p:txBody>
+      </p:sp>
+      <p:sp>
+        <p:nvSpPr>
+          <p:cNvPr id="17" name="Text 15"/>
+          <p:cNvSpPr/>
+          <p:nvPr/>
+        </p:nvSpPr>
+        <p:spPr>
+          <a:xfrm>
+            <a:off x="822960" y="3566160"/>
+            <a:ext cx="8961120" cy="320040"/>
+          </a:xfrm>
+          <a:prstGeom prst="rect">
+            <a:avLst/>
+          </a:prstGeom>
+          <a:noFill/>
+          <a:ln/>
+        </p:spPr>
+        <p:txBody>
+          <a:bodyPr wrap="square" lIns="0" tIns="0" rIns="0" bIns="0" rtlCol="0" anchor="ctr"/>
+          <a:lstStyle/>
+          <a:p>
+            <a:pPr marL="0" indent="0">
+              <a:buNone/>
+            </a:pPr>
+            <a:r>
+              <a:rPr lang="en-US" sz="1150" dirty="0">
+                <a:solidFill>
+                  <a:srgbClr val="212A31"/>
+                </a:solidFill>
+                <a:latin typeface="Open Sans" pitchFamily="34" charset="0"/>
+                <a:ea typeface="Open Sans" pitchFamily="34" charset="-122"/>
+                <a:cs typeface="Open Sans" pitchFamily="34" charset="-120"/>
+              </a:rPr>
+              <a:t>npmjs.com/package/@design-system-ms/ds-sis</a:t>
+            </a:r>
+            <a:endParaRPr lang="en-US" sz="1150" dirty="0"/>
+          </a:p>
+        </p:txBody>
+      </p:sp>
+      <p:sp>
+        <p:nvSpPr>
+          <p:cNvPr id="18" name="Text 16"/>
+          <p:cNvSpPr/>
+          <p:nvPr/>
+        </p:nvSpPr>
+        <p:spPr>
+          <a:xfrm>
+            <a:off x="3840480" y="3218688"/>
+            <a:ext cx="7680960" cy="365760"/>
+          </a:xfrm>
+          <a:prstGeom prst="rect">
+            <a:avLst/>
+          </a:prstGeom>
+          <a:noFill/>
+          <a:ln/>
+        </p:spPr>
+        <p:txBody>
+          <a:bodyPr wrap="square" lIns="0" tIns="0" rIns="0" bIns="0" rtlCol="0" anchor="ctr"/>
+          <a:lstStyle/>
+          <a:p>
+            <a:pPr marL="0" indent="0">
+              <a:buNone/>
+            </a:pPr>
+            <a:r>
+              <a:rPr lang="en-US" sz="1150" i="1" dirty="0">
+                <a:solidFill>
+                  <a:srgbClr val="545D64"/>
+                </a:solidFill>
+                <a:latin typeface="Open Sans" pitchFamily="34" charset="0"/>
+                <a:ea typeface="Open Sans" pitchFamily="34" charset="-122"/>
+                <a:cs typeface="Open Sans" pitchFamily="34" charset="-120"/>
+              </a:rPr>
+              <a:t>@design-system-ms/ds-sis instalável via npm i, hoje</a:t>
+            </a:r>
+            <a:endParaRPr lang="en-US" sz="1150" dirty="0"/>
+          </a:p>
+        </p:txBody>
+      </p:sp>
+      <p:sp>
+        <p:nvSpPr>
+          <p:cNvPr id="19" name="Shape 17"/>
+          <p:cNvSpPr/>
+          <p:nvPr/>
+        </p:nvSpPr>
+        <p:spPr>
+          <a:xfrm>
+            <a:off x="548640" y="4114800"/>
+            <a:ext cx="11091672" cy="868680"/>
+          </a:xfrm>
+          <a:prstGeom prst="rect">
+            <a:avLst/>
+          </a:prstGeom>
+          <a:solidFill>
+            <a:srgbClr val="FFFFFF"/>
+          </a:solidFill>
+          <a:ln/>
+        </p:spPr>
+      </p:sp>
+      <p:sp>
+        <p:nvSpPr>
+          <p:cNvPr id="20" name="Shape 18"/>
+          <p:cNvSpPr/>
+          <p:nvPr/>
+        </p:nvSpPr>
+        <p:spPr>
+          <a:xfrm>
+            <a:off x="548640" y="4114800"/>
+            <a:ext cx="91440" cy="868680"/>
+          </a:xfrm>
+          <a:prstGeom prst="rect">
+            <a:avLst/>
+          </a:prstGeom>
+          <a:solidFill>
+            <a:srgbClr val="198038"/>
+          </a:solidFill>
+          <a:ln/>
+        </p:spPr>
+      </p:sp>
+      <p:sp>
+        <p:nvSpPr>
+          <p:cNvPr id="21" name="Text 19"/>
+          <p:cNvSpPr/>
+          <p:nvPr/>
+        </p:nvSpPr>
+        <p:spPr>
+          <a:xfrm>
+            <a:off x="822960" y="4224528"/>
+            <a:ext cx="2926080" cy="365760"/>
+          </a:xfrm>
+          <a:prstGeom prst="rect">
+            <a:avLst/>
+          </a:prstGeom>
+          <a:noFill/>
+          <a:ln/>
+        </p:spPr>
+        <p:txBody>
+          <a:bodyPr wrap="square" lIns="0" tIns="0" rIns="0" bIns="0" rtlCol="0" anchor="ctr"/>
+          <a:lstStyle/>
+          <a:p>
+            <a:pPr marL="0" indent="0">
+              <a:buNone/>
+            </a:pPr>
+            <a:r>
+              <a:rPr lang="en-US" sz="1400" b="1" dirty="0">
+                <a:solidFill>
+                  <a:srgbClr val="004F9F"/>
+                </a:solidFill>
+                <a:latin typeface="Open Sans" pitchFamily="34" charset="0"/>
+                <a:ea typeface="Open Sans" pitchFamily="34" charset="-122"/>
+                <a:cs typeface="Open Sans" pitchFamily="34" charset="-120"/>
+              </a:rPr>
+              <a:t>Documentação viva</a:t>
+            </a:r>
+            <a:endParaRPr lang="en-US" sz="1400" dirty="0"/>
+          </a:p>
+        </p:txBody>
+      </p:sp>
+      <p:sp>
+        <p:nvSpPr>
+          <p:cNvPr id="22" name="Text 20"/>
+          <p:cNvSpPr/>
+          <p:nvPr/>
+        </p:nvSpPr>
+        <p:spPr>
+          <a:xfrm>
+            <a:off x="822960" y="4572000"/>
+            <a:ext cx="8961120" cy="320040"/>
+          </a:xfrm>
+          <a:prstGeom prst="rect">
+            <a:avLst/>
+          </a:prstGeom>
+          <a:noFill/>
+          <a:ln/>
+        </p:spPr>
+        <p:txBody>
+          <a:bodyPr wrap="square" lIns="0" tIns="0" rIns="0" bIns="0" rtlCol="0" anchor="ctr"/>
+          <a:lstStyle/>
+          <a:p>
+            <a:pPr marL="0" indent="0">
+              <a:buNone/>
+            </a:pPr>
+            <a:r>
+              <a:rPr lang="en-US" sz="1150" dirty="0">
+                <a:solidFill>
+                  <a:srgbClr val="212A31"/>
+                </a:solidFill>
+                <a:latin typeface="Open Sans" pitchFamily="34" charset="0"/>
+                <a:ea typeface="Open Sans" pitchFamily="34" charset="-122"/>
+                <a:cs typeface="Open Sans" pitchFamily="34" charset="-120"/>
+              </a:rPr>
+              <a:t>fabioramos-02.github.io/DS-MS-Design-System</a:t>
+            </a:r>
+            <a:endParaRPr lang="en-US" sz="1150" dirty="0"/>
+          </a:p>
+        </p:txBody>
+      </p:sp>
+      <p:sp>
+        <p:nvSpPr>
+          <p:cNvPr id="23" name="Text 21"/>
+          <p:cNvSpPr/>
+          <p:nvPr/>
+        </p:nvSpPr>
+        <p:spPr>
+          <a:xfrm>
+            <a:off x="3840480" y="4224528"/>
+            <a:ext cx="7680960" cy="365760"/>
+          </a:xfrm>
+          <a:prstGeom prst="rect">
+            <a:avLst/>
+          </a:prstGeom>
+          <a:noFill/>
+          <a:ln/>
+        </p:spPr>
+        <p:txBody>
+          <a:bodyPr wrap="square" lIns="0" tIns="0" rIns="0" bIns="0" rtlCol="0" anchor="ctr"/>
+          <a:lstStyle/>
+          <a:p>
+            <a:pPr marL="0" indent="0">
+              <a:buNone/>
+            </a:pPr>
+            <a:r>
+              <a:rPr lang="en-US" sz="1150" i="1" dirty="0">
+                <a:solidFill>
+                  <a:srgbClr val="545D64"/>
+                </a:solidFill>
+                <a:latin typeface="Open Sans" pitchFamily="34" charset="0"/>
+                <a:ea typeface="Open Sans" pitchFamily="34" charset="-122"/>
+                <a:cs typeface="Open Sans" pitchFamily="34" charset="-120"/>
+              </a:rPr>
+              <a:t>Storybook publicado via GitHub Pages — substitui as imagens</a:t>
+            </a:r>
+            <a:endParaRPr lang="en-US" sz="1150" dirty="0"/>
+          </a:p>
+        </p:txBody>
+      </p:sp>
+      <p:sp>
+        <p:nvSpPr>
+          <p:cNvPr id="24" name="Shape 22"/>
+          <p:cNvSpPr/>
+          <p:nvPr/>
+        </p:nvSpPr>
+        <p:spPr>
+          <a:xfrm>
+            <a:off x="548640" y="5120640"/>
+            <a:ext cx="11091672" cy="868680"/>
+          </a:xfrm>
+          <a:prstGeom prst="rect">
+            <a:avLst/>
+          </a:prstGeom>
+          <a:solidFill>
+            <a:srgbClr val="FFFFFF"/>
+          </a:solidFill>
+          <a:ln/>
+        </p:spPr>
+      </p:sp>
+      <p:sp>
+        <p:nvSpPr>
+          <p:cNvPr id="25" name="Shape 23"/>
+          <p:cNvSpPr/>
+          <p:nvPr/>
+        </p:nvSpPr>
+        <p:spPr>
+          <a:xfrm>
+            <a:off x="548640" y="5120640"/>
+            <a:ext cx="91440" cy="868680"/>
+          </a:xfrm>
+          <a:prstGeom prst="rect">
+            <a:avLst/>
+          </a:prstGeom>
+          <a:solidFill>
+            <a:srgbClr val="198038"/>
+          </a:solidFill>
+          <a:ln/>
+        </p:spPr>
+      </p:sp>
+      <p:sp>
+        <p:nvSpPr>
+          <p:cNvPr id="26" name="Text 24"/>
+          <p:cNvSpPr/>
+          <p:nvPr/>
+        </p:nvSpPr>
+        <p:spPr>
+          <a:xfrm>
+            <a:off x="822960" y="5230368"/>
+            <a:ext cx="2926080" cy="365760"/>
+          </a:xfrm>
+          <a:prstGeom prst="rect">
+            <a:avLst/>
+          </a:prstGeom>
+          <a:noFill/>
+          <a:ln/>
+        </p:spPr>
+        <p:txBody>
+          <a:bodyPr wrap="square" lIns="0" tIns="0" rIns="0" bIns="0" rtlCol="0" anchor="ctr"/>
+          <a:lstStyle/>
+          <a:p>
+            <a:pPr marL="0" indent="0">
+              <a:buNone/>
+            </a:pPr>
+            <a:r>
+              <a:rPr lang="en-US" sz="1400" b="1" dirty="0">
+                <a:solidFill>
+                  <a:srgbClr val="004F9F"/>
+                </a:solidFill>
+                <a:latin typeface="Open Sans" pitchFamily="34" charset="0"/>
+                <a:ea typeface="Open Sans" pitchFamily="34" charset="-122"/>
+                <a:cs typeface="Open Sans" pitchFamily="34" charset="-120"/>
+              </a:rPr>
+              <a:t>Repositório</a:t>
+            </a:r>
+            <a:endParaRPr lang="en-US" sz="1400" dirty="0"/>
+          </a:p>
+        </p:txBody>
+      </p:sp>
+      <p:sp>
+        <p:nvSpPr>
+          <p:cNvPr id="27" name="Text 25"/>
+          <p:cNvSpPr/>
+          <p:nvPr/>
+        </p:nvSpPr>
+        <p:spPr>
+          <a:xfrm>
+            <a:off x="822960" y="5577840"/>
+            <a:ext cx="8961120" cy="320040"/>
+          </a:xfrm>
+          <a:prstGeom prst="rect">
+            <a:avLst/>
+          </a:prstGeom>
+          <a:noFill/>
+          <a:ln/>
+        </p:spPr>
+        <p:txBody>
+          <a:bodyPr wrap="square" lIns="0" tIns="0" rIns="0" bIns="0" rtlCol="0" anchor="ctr"/>
+          <a:lstStyle/>
+          <a:p>
+            <a:pPr marL="0" indent="0">
+              <a:buNone/>
+            </a:pPr>
+            <a:r>
+              <a:rPr lang="en-US" sz="1150" dirty="0">
+                <a:solidFill>
+                  <a:srgbClr val="212A31"/>
+                </a:solidFill>
+                <a:latin typeface="Open Sans" pitchFamily="34" charset="0"/>
+                <a:ea typeface="Open Sans" pitchFamily="34" charset="-122"/>
+                <a:cs typeface="Open Sans" pitchFamily="34" charset="-120"/>
+              </a:rPr>
+              <a:t>github.com/fabioramos-02/DS-MS-Design-System</a:t>
+            </a:r>
+            <a:endParaRPr lang="en-US" sz="1150" dirty="0"/>
+          </a:p>
+        </p:txBody>
+      </p:sp>
+      <p:sp>
+        <p:nvSpPr>
+          <p:cNvPr id="28" name="Text 26"/>
+          <p:cNvSpPr/>
+          <p:nvPr/>
+        </p:nvSpPr>
+        <p:spPr>
+          <a:xfrm>
+            <a:off x="3840480" y="5230368"/>
+            <a:ext cx="7680960" cy="365760"/>
+          </a:xfrm>
+          <a:prstGeom prst="rect">
+            <a:avLst/>
+          </a:prstGeom>
+          <a:noFill/>
+          <a:ln/>
+        </p:spPr>
+        <p:txBody>
+          <a:bodyPr wrap="square" lIns="0" tIns="0" rIns="0" bIns="0" rtlCol="0" anchor="ctr"/>
+          <a:lstStyle/>
+          <a:p>
+            <a:pPr marL="0" indent="0">
+              <a:buNone/>
+            </a:pPr>
+            <a:r>
+              <a:rPr lang="en-US" sz="1150" i="1" dirty="0">
+                <a:solidFill>
+                  <a:srgbClr val="545D64"/>
+                </a:solidFill>
+                <a:latin typeface="Open Sans" pitchFamily="34" charset="0"/>
+                <a:ea typeface="Open Sans" pitchFamily="34" charset="-122"/>
+                <a:cs typeface="Open Sans" pitchFamily="34" charset="-120"/>
+              </a:rPr>
+              <a:t>Código aberto, CI automático a cada push</a:t>
+            </a:r>
+            <a:endParaRPr lang="en-US" sz="1150" dirty="0"/>
+          </a:p>
+        </p:txBody>
+      </p:sp>
+      <p:sp>
+        <p:nvSpPr>
+          <p:cNvPr id="29" name="Text 27"/>
+          <p:cNvSpPr/>
+          <p:nvPr/>
+        </p:nvSpPr>
+        <p:spPr>
+          <a:xfrm>
+            <a:off x="457200" y="6446520"/>
+            <a:ext cx="8686800" cy="274320"/>
+          </a:xfrm>
+          <a:prstGeom prst="rect">
+            <a:avLst/>
+          </a:prstGeom>
+          <a:noFill/>
+          <a:ln/>
+        </p:spPr>
+        <p:txBody>
+          <a:bodyPr wrap="square" lIns="0" tIns="0" rIns="0" bIns="0" rtlCol="0" anchor="ctr"/>
+          <a:lstStyle/>
+          <a:p>
+            <a:pPr marL="0" indent="0" algn="l">
+              <a:buNone/>
+            </a:pPr>
+            <a:r>
+              <a:rPr lang="en-US" sz="900" dirty="0">
+                <a:solidFill>
+                  <a:srgbClr val="CCDCEC"/>
+                </a:solidFill>
+                <a:latin typeface="Open Sans" pitchFamily="34" charset="0"/>
+                <a:ea typeface="Open Sans" pitchFamily="34" charset="-122"/>
+                <a:cs typeface="Open Sans" pitchFamily="34" charset="-120"/>
+              </a:rPr>
+              <a:t>SETDIG — Secretaria-Executiva de Transformação Digital · Governo de MS</a:t>
+            </a:r>
+            <a:endParaRPr lang="en-US" sz="900" dirty="0"/>
+          </a:p>
+        </p:txBody>
+      </p:sp>
+      <p:sp>
+        <p:nvSpPr>
+          <p:cNvPr id="30" name="Text 28"/>
+          <p:cNvSpPr/>
+          <p:nvPr/>
+        </p:nvSpPr>
+        <p:spPr>
+          <a:xfrm>
+            <a:off x="11064240" y="6446520"/>
+            <a:ext cx="731520" cy="274320"/>
+          </a:xfrm>
+          <a:prstGeom prst="rect">
+            <a:avLst/>
+          </a:prstGeom>
+          <a:noFill/>
+          <a:ln/>
+        </p:spPr>
+        <p:txBody>
+          <a:bodyPr wrap="square" lIns="0" tIns="0" rIns="0" bIns="0" rtlCol="0" anchor="ctr"/>
+          <a:lstStyle/>
+          <a:p>
+            <a:pPr marL="0" indent="0" algn="r">
+              <a:buNone/>
+            </a:pPr>
+            <a:r>
+              <a:rPr lang="en-US" sz="900" dirty="0">
+                <a:solidFill>
+                  <a:srgbClr val="CCDCEC"/>
+                </a:solidFill>
+                <a:latin typeface="Open Sans" pitchFamily="34" charset="0"/>
+                <a:ea typeface="Open Sans" pitchFamily="34" charset="-122"/>
+                <a:cs typeface="Open Sans" pitchFamily="34" charset="-120"/>
+              </a:rPr>
+              <a:t>06 / 7</a:t>
+            </a:r>
+            <a:endParaRPr lang="en-US" sz="900" dirty="0"/>
+          </a:p>
+        </p:txBody>
+      </p:sp>
+    </p:spTree>
+  </p:cSld>
+  <p:clrMapOvr>
+    <a:masterClrMapping/>
+  </p:clrMapOvr>
+</p:sld>
+</file>
+
+<file path=ppt/slides/slide7.xml><?xml version="1.0" encoding="utf-8"?>
+<p:sld xmlns:a="http://schemas.openxmlformats.org/drawingml/2006/main" xmlns:r="http://schemas.openxmlformats.org/officeDocument/2006/relationships" xmlns:p="http://schemas.openxmlformats.org/presentationml/2006/main">
+  <p:cSld name="Slide 7">
+    <p:bg>
+      <p:bgPr>
+        <a:solidFill>
+          <a:srgbClr val="FFFFFF"/>
+        </a:solidFill>
+        <a:effectLst/>
+      </p:bgPr>
+    </p:bg>
+    <p:spTree>
+      <p:nvGrpSpPr>
+        <p:cNvPr id="1" name=""/>
+        <p:cNvGrpSpPr/>
+        <p:nvPr/>
+      </p:nvGrpSpPr>
+      <p:grpSpPr>
+        <a:xfrm>
+          <a:off x="0" y="0"/>
+          <a:ext cx="0" cy="0"/>
+          <a:chOff x="0" y="0"/>
+          <a:chExt cx="0" cy="0"/>
+        </a:xfrm>
+      </p:grpSpPr>
+      <p:sp>
+        <p:nvSpPr>
+          <p:cNvPr id="2" name="Shape 0"/>
+          <p:cNvSpPr/>
+          <p:nvPr/>
+        </p:nvSpPr>
+        <p:spPr>
+          <a:xfrm>
+            <a:off x="0" y="0"/>
+            <a:ext cx="146304" cy="6858000"/>
+          </a:xfrm>
+          <a:prstGeom prst="rect">
+            <a:avLst/>
+          </a:prstGeom>
+          <a:solidFill>
+            <a:srgbClr val="004F9F"/>
+          </a:solidFill>
+          <a:ln/>
+        </p:spPr>
+      </p:sp>
+      <p:sp>
+        <p:nvSpPr>
+          <p:cNvPr id="3" name="Text 1"/>
+          <p:cNvSpPr/>
+          <p:nvPr/>
+        </p:nvSpPr>
+        <p:spPr>
+          <a:xfrm>
+            <a:off x="548640" y="411480"/>
+            <a:ext cx="10058400" cy="640080"/>
+          </a:xfrm>
+          <a:prstGeom prst="rect">
+            <a:avLst/>
+          </a:prstGeom>
+          <a:noFill/>
+          <a:ln/>
+        </p:spPr>
+        <p:txBody>
+          <a:bodyPr wrap="square" lIns="0" tIns="0" rIns="0" bIns="0" rtlCol="0" anchor="ctr"/>
+          <a:lstStyle/>
+          <a:p>
+            <a:pPr marL="0" indent="0">
+              <a:buNone/>
+            </a:pPr>
+            <a:r>
+              <a:rPr lang="en-US" sz="3400" b="1" dirty="0">
+                <a:solidFill>
+                  <a:srgbClr val="004F9F"/>
+                </a:solidFill>
+                <a:latin typeface="Open Sans" pitchFamily="34" charset="0"/>
+                <a:ea typeface="Open Sans" pitchFamily="34" charset="-122"/>
+                <a:cs typeface="Open Sans" pitchFamily="34" charset="-120"/>
+              </a:rPr>
               <a:t>Próximos passos</a:t>
             </a:r>
             <a:endParaRPr lang="en-US" sz="3400" dirty="0"/>
@@ -4110,14 +6131,14 @@
         </p:nvSpPr>
         <p:spPr>
           <a:xfrm>
-            <a:off x="594360" y="1463040"/>
+            <a:off x="594360" y="1417320"/>
             <a:ext cx="502920" cy="502920"/>
           </a:xfrm>
           <a:prstGeom prst="ellipse">
             <a:avLst/>
           </a:prstGeom>
           <a:solidFill>
-            <a:srgbClr val="FFFFFF"/>
+            <a:srgbClr val="004F9F"/>
           </a:solidFill>
           <a:ln/>
         </p:spPr>
@@ -4130,7 +6151,7 @@
         </p:nvSpPr>
         <p:spPr>
           <a:xfrm>
-            <a:off x="594360" y="1463040"/>
+            <a:off x="594360" y="1417320"/>
             <a:ext cx="502920" cy="502920"/>
           </a:xfrm>
           <a:prstGeom prst="rect">
@@ -4149,7 +6170,7 @@
             <a:r>
               <a:rPr lang="en-US" sz="2200" b="1" dirty="0">
                 <a:solidFill>
-                  <a:srgbClr val="004F9F"/>
+                  <a:srgbClr val="FFFFFF"/>
                 </a:solidFill>
                 <a:latin typeface="Open Sans" pitchFamily="34" charset="0"/>
                 <a:ea typeface="Open Sans" pitchFamily="34" charset="-122"/>
@@ -4169,8 +6190,8 @@
         </p:nvSpPr>
         <p:spPr>
           <a:xfrm>
-            <a:off x="1280160" y="1417320"/>
-            <a:ext cx="4937760" cy="365760"/>
+            <a:off x="1280160" y="1371600"/>
+            <a:ext cx="5120640" cy="365760"/>
           </a:xfrm>
           <a:prstGeom prst="rect">
             <a:avLst/>
@@ -4186,17 +6207,17 @@
               <a:buNone/>
             </a:pPr>
             <a:r>
-              <a:rPr lang="en-US" sz="1700" b="1" dirty="0">
-                <a:solidFill>
-                  <a:srgbClr val="FFFFFF"/>
-                </a:solidFill>
-                <a:latin typeface="Open Sans" pitchFamily="34" charset="0"/>
-                <a:ea typeface="Open Sans" pitchFamily="34" charset="-122"/>
-                <a:cs typeface="Open Sans" pitchFamily="34" charset="-120"/>
-              </a:rPr>
-              <a:t>Tokens do Figma</a:t>
-            </a:r>
-            <a:endParaRPr lang="en-US" sz="1700" dirty="0"/>
+              <a:rPr lang="en-US" sz="1600" b="1" dirty="0">
+                <a:solidFill>
+                  <a:srgbClr val="212A31"/>
+                </a:solidFill>
+                <a:latin typeface="Open Sans" pitchFamily="34" charset="0"/>
+                <a:ea typeface="Open Sans" pitchFamily="34" charset="-122"/>
+                <a:cs typeface="Open Sans" pitchFamily="34" charset="-120"/>
+              </a:rPr>
+              <a:t>Tokens do Figma oficial</a:t>
+            </a:r>
+            <a:endParaRPr lang="en-US" sz="1600" dirty="0"/>
           </a:p>
         </p:txBody>
       </p:sp>
@@ -4208,8 +6229,8 @@
         </p:nvSpPr>
         <p:spPr>
           <a:xfrm>
-            <a:off x="1280160" y="1764792"/>
-            <a:ext cx="5120640" cy="457200"/>
+            <a:off x="1280160" y="1719072"/>
+            <a:ext cx="5303520" cy="502920"/>
           </a:xfrm>
           <a:prstGeom prst="rect">
             <a:avLst/>
@@ -4225,17 +6246,17 @@
               <a:buNone/>
             </a:pPr>
             <a:r>
-              <a:rPr lang="en-US" sz="1250" dirty="0">
-                <a:solidFill>
-                  <a:srgbClr val="CCDCEC"/>
-                </a:solidFill>
-                <a:latin typeface="Open Sans" pitchFamily="34" charset="0"/>
-                <a:ea typeface="Open Sans" pitchFamily="34" charset="-122"/>
-                <a:cs typeface="Open Sans" pitchFamily="34" charset="-120"/>
-              </a:rPr>
-              <a:t>Exportar via Tokens Studio; o CSS deixa de ser escrito à mão.</a:t>
-            </a:r>
-            <a:endParaRPr lang="en-US" sz="1250" dirty="0"/>
+              <a:rPr lang="en-US" sz="1200" dirty="0">
+                <a:solidFill>
+                  <a:srgbClr val="545D64"/>
+                </a:solidFill>
+                <a:latin typeface="Open Sans" pitchFamily="34" charset="0"/>
+                <a:ea typeface="Open Sans" pitchFamily="34" charset="-122"/>
+                <a:cs typeface="Open Sans" pitchFamily="34" charset="-120"/>
+              </a:rPr>
+              <a:t>Hoje os tokens são transcritos à mão; falta o export real via Tokens Studio.</a:t>
+            </a:r>
+            <a:endParaRPr lang="en-US" sz="1200" dirty="0"/>
           </a:p>
         </p:txBody>
       </p:sp>
@@ -4254,7 +6275,7 @@
             <a:avLst/>
           </a:prstGeom>
           <a:solidFill>
-            <a:srgbClr val="FFFFFF"/>
+            <a:srgbClr val="004F9F"/>
           </a:solidFill>
           <a:ln/>
         </p:spPr>
@@ -4286,7 +6307,7 @@
             <a:r>
               <a:rPr lang="en-US" sz="2200" b="1" dirty="0">
                 <a:solidFill>
-                  <a:srgbClr val="004F9F"/>
+                  <a:srgbClr val="FFFFFF"/>
                 </a:solidFill>
                 <a:latin typeface="Open Sans" pitchFamily="34" charset="0"/>
                 <a:ea typeface="Open Sans" pitchFamily="34" charset="-122"/>
@@ -4307,7 +6328,7 @@
         <p:spPr>
           <a:xfrm>
             <a:off x="1280160" y="2331720"/>
-            <a:ext cx="4937760" cy="365760"/>
+            <a:ext cx="5120640" cy="365760"/>
           </a:xfrm>
           <a:prstGeom prst="rect">
             <a:avLst/>
@@ -4323,7 +6344,105 @@
               <a:buNone/>
             </a:pPr>
             <a:r>
-              <a:rPr lang="en-US" sz="1700" b="1" dirty="0">
+              <a:rPr lang="en-US" sz="1600" b="1" dirty="0">
+                <a:solidFill>
+                  <a:srgbClr val="212A31"/>
+                </a:solidFill>
+                <a:latin typeface="Open Sans" pitchFamily="34" charset="0"/>
+                <a:ea typeface="Open Sans" pitchFamily="34" charset="-122"/>
+                <a:cs typeface="Open Sans" pitchFamily="34" charset="-120"/>
+              </a:rPr>
+              <a:t>31 componentes restantes</a:t>
+            </a:r>
+            <a:endParaRPr lang="en-US" sz="1600" dirty="0"/>
+          </a:p>
+        </p:txBody>
+      </p:sp>
+      <p:sp>
+        <p:nvSpPr>
+          <p:cNvPr id="11" name="Text 9"/>
+          <p:cNvSpPr/>
+          <p:nvPr/>
+        </p:nvSpPr>
+        <p:spPr>
+          <a:xfrm>
+            <a:off x="1280160" y="2679192"/>
+            <a:ext cx="5303520" cy="502920"/>
+          </a:xfrm>
+          <a:prstGeom prst="rect">
+            <a:avLst/>
+          </a:prstGeom>
+          <a:noFill/>
+          <a:ln/>
+        </p:spPr>
+        <p:txBody>
+          <a:bodyPr wrap="square" lIns="0" tIns="0" rIns="0" bIns="0" rtlCol="0" anchor="ctr"/>
+          <a:lstStyle/>
+          <a:p>
+            <a:pPr marL="0" indent="0">
+              <a:buNone/>
+            </a:pPr>
+            <a:r>
+              <a:rPr lang="en-US" sz="1200" dirty="0">
+                <a:solidFill>
+                  <a:srgbClr val="545D64"/>
+                </a:solidFill>
+                <a:latin typeface="Open Sans" pitchFamily="34" charset="0"/>
+                <a:ea typeface="Open Sans" pitchFamily="34" charset="-122"/>
+                <a:cs typeface="Open Sans" pitchFamily="34" charset="-120"/>
+              </a:rPr>
+              <a:t>Accordion, Breadcrumb, Dropdown, Menu, Table e outros — exigem acesso ao Figma.</a:t>
+            </a:r>
+            <a:endParaRPr lang="en-US" sz="1200" dirty="0"/>
+          </a:p>
+        </p:txBody>
+      </p:sp>
+      <p:sp>
+        <p:nvSpPr>
+          <p:cNvPr id="12" name="Shape 10"/>
+          <p:cNvSpPr/>
+          <p:nvPr/>
+        </p:nvSpPr>
+        <p:spPr>
+          <a:xfrm>
+            <a:off x="594360" y="3337560"/>
+            <a:ext cx="502920" cy="502920"/>
+          </a:xfrm>
+          <a:prstGeom prst="ellipse">
+            <a:avLst/>
+          </a:prstGeom>
+          <a:solidFill>
+            <a:srgbClr val="004F9F"/>
+          </a:solidFill>
+          <a:ln/>
+        </p:spPr>
+      </p:sp>
+      <p:sp>
+        <p:nvSpPr>
+          <p:cNvPr id="13" name="Text 11"/>
+          <p:cNvSpPr/>
+          <p:nvPr/>
+        </p:nvSpPr>
+        <p:spPr>
+          <a:xfrm>
+            <a:off x="594360" y="3337560"/>
+            <a:ext cx="502920" cy="502920"/>
+          </a:xfrm>
+          <a:prstGeom prst="rect">
+            <a:avLst/>
+          </a:prstGeom>
+          <a:noFill/>
+          <a:ln/>
+        </p:spPr>
+        <p:txBody>
+          <a:bodyPr wrap="square" lIns="0" tIns="0" rIns="0" bIns="0" rtlCol="0" anchor="ctr"/>
+          <a:lstStyle/>
+          <a:p>
+            <a:pPr marL="0" indent="0" algn="ctr">
+              <a:buNone/>
+            </a:pPr>
+            <a:r>
+              <a:rPr lang="en-US" sz="2200" b="1" dirty="0">
                 <a:solidFill>
                   <a:srgbClr val="FFFFFF"/>
                 </a:solidFill>
@@ -4331,22 +6450,22 @@
                 <a:ea typeface="Open Sans" pitchFamily="34" charset="-122"/>
                 <a:cs typeface="Open Sans" pitchFamily="34" charset="-120"/>
               </a:rPr>
-              <a:t>Top 5 componentes</a:t>
-            </a:r>
-            <a:endParaRPr lang="en-US" sz="1700" dirty="0"/>
-          </a:p>
-        </p:txBody>
-      </p:sp>
-      <p:sp>
-        <p:nvSpPr>
-          <p:cNvPr id="11" name="Text 9"/>
-          <p:cNvSpPr/>
-          <p:nvPr/>
-        </p:nvSpPr>
-        <p:spPr>
-          <a:xfrm>
-            <a:off x="1280160" y="2679192"/>
-            <a:ext cx="5120640" cy="457200"/>
+              <a:t>3</a:t>
+            </a:r>
+            <a:endParaRPr lang="en-US" sz="2200" dirty="0"/>
+          </a:p>
+        </p:txBody>
+      </p:sp>
+      <p:sp>
+        <p:nvSpPr>
+          <p:cNvPr id="14" name="Text 12"/>
+          <p:cNvSpPr/>
+          <p:nvPr/>
+        </p:nvSpPr>
+        <p:spPr>
+          <a:xfrm>
+            <a:off x="1280160" y="3291840"/>
+            <a:ext cx="5120640" cy="365760"/>
           </a:xfrm>
           <a:prstGeom prst="rect">
             <a:avLst/>
@@ -4362,49 +6481,88 @@
               <a:buNone/>
             </a:pPr>
             <a:r>
-              <a:rPr lang="en-US" sz="1250" dirty="0">
-                <a:solidFill>
-                  <a:srgbClr val="CCDCEC"/>
-                </a:solidFill>
-                <a:latin typeface="Open Sans" pitchFamily="34" charset="0"/>
-                <a:ea typeface="Open Sans" pitchFamily="34" charset="-122"/>
-                <a:cs typeface="Open Sans" pitchFamily="34" charset="-120"/>
-              </a:rPr>
-              <a:t>Button, input, card, busca e header (1º Web Component).</a:t>
-            </a:r>
-            <a:endParaRPr lang="en-US" sz="1250" dirty="0"/>
-          </a:p>
-        </p:txBody>
-      </p:sp>
-      <p:sp>
-        <p:nvSpPr>
-          <p:cNvPr id="12" name="Shape 10"/>
-          <p:cNvSpPr/>
-          <p:nvPr/>
-        </p:nvSpPr>
-        <p:spPr>
-          <a:xfrm>
-            <a:off x="594360" y="3291840"/>
+              <a:rPr lang="en-US" sz="1600" b="1" dirty="0">
+                <a:solidFill>
+                  <a:srgbClr val="212A31"/>
+                </a:solidFill>
+                <a:latin typeface="Open Sans" pitchFamily="34" charset="0"/>
+                <a:ea typeface="Open Sans" pitchFamily="34" charset="-122"/>
+                <a:cs typeface="Open Sans" pitchFamily="34" charset="-120"/>
+              </a:rPr>
+              <a:t>Gate de acessibilidade automático</a:t>
+            </a:r>
+            <a:endParaRPr lang="en-US" sz="1600" dirty="0"/>
+          </a:p>
+        </p:txBody>
+      </p:sp>
+      <p:sp>
+        <p:nvSpPr>
+          <p:cNvPr id="15" name="Text 13"/>
+          <p:cNvSpPr/>
+          <p:nvPr/>
+        </p:nvSpPr>
+        <p:spPr>
+          <a:xfrm>
+            <a:off x="1280160" y="3639312"/>
+            <a:ext cx="5303520" cy="502920"/>
+          </a:xfrm>
+          <a:prstGeom prst="rect">
+            <a:avLst/>
+          </a:prstGeom>
+          <a:noFill/>
+          <a:ln/>
+        </p:spPr>
+        <p:txBody>
+          <a:bodyPr wrap="square" lIns="0" tIns="0" rIns="0" bIns="0" rtlCol="0" anchor="ctr"/>
+          <a:lstStyle/>
+          <a:p>
+            <a:pPr marL="0" indent="0">
+              <a:buNone/>
+            </a:pPr>
+            <a:r>
+              <a:rPr lang="en-US" sz="1200" dirty="0">
+                <a:solidFill>
+                  <a:srgbClr val="545D64"/>
+                </a:solidFill>
+                <a:latin typeface="Open Sans" pitchFamily="34" charset="0"/>
+                <a:ea typeface="Open Sans" pitchFamily="34" charset="-122"/>
+                <a:cs typeface="Open Sans" pitchFamily="34" charset="-120"/>
+              </a:rPr>
+              <a:t>CI já builda; falta ligar axe-core como bloqueio de PR.</a:t>
+            </a:r>
+            <a:endParaRPr lang="en-US" sz="1200" dirty="0"/>
+          </a:p>
+        </p:txBody>
+      </p:sp>
+      <p:sp>
+        <p:nvSpPr>
+          <p:cNvPr id="16" name="Shape 14"/>
+          <p:cNvSpPr/>
+          <p:nvPr/>
+        </p:nvSpPr>
+        <p:spPr>
+          <a:xfrm>
+            <a:off x="594360" y="4297680"/>
             <a:ext cx="502920" cy="502920"/>
           </a:xfrm>
           <a:prstGeom prst="ellipse">
             <a:avLst/>
           </a:prstGeom>
           <a:solidFill>
-            <a:srgbClr val="FFFFFF"/>
-          </a:solidFill>
-          <a:ln/>
-        </p:spPr>
-      </p:sp>
-      <p:sp>
-        <p:nvSpPr>
-          <p:cNvPr id="13" name="Text 11"/>
-          <p:cNvSpPr/>
-          <p:nvPr/>
-        </p:nvSpPr>
-        <p:spPr>
-          <a:xfrm>
-            <a:off x="594360" y="3291840"/>
+            <a:srgbClr val="004F9F"/>
+          </a:solidFill>
+          <a:ln/>
+        </p:spPr>
+      </p:sp>
+      <p:sp>
+        <p:nvSpPr>
+          <p:cNvPr id="17" name="Text 15"/>
+          <p:cNvSpPr/>
+          <p:nvPr/>
+        </p:nvSpPr>
+        <p:spPr>
+          <a:xfrm>
+            <a:off x="594360" y="4297680"/>
             <a:ext cx="502920" cy="502920"/>
           </a:xfrm>
           <a:prstGeom prst="rect">
@@ -4423,13 +6581,13 @@
             <a:r>
               <a:rPr lang="en-US" sz="2200" b="1" dirty="0">
                 <a:solidFill>
-                  <a:srgbClr val="004F9F"/>
-                </a:solidFill>
-                <a:latin typeface="Open Sans" pitchFamily="34" charset="0"/>
-                <a:ea typeface="Open Sans" pitchFamily="34" charset="-122"/>
-                <a:cs typeface="Open Sans" pitchFamily="34" charset="-120"/>
-              </a:rPr>
-              <a:t>3</a:t>
+                  <a:srgbClr val="FFFFFF"/>
+                </a:solidFill>
+                <a:latin typeface="Open Sans" pitchFamily="34" charset="0"/>
+                <a:ea typeface="Open Sans" pitchFamily="34" charset="-122"/>
+                <a:cs typeface="Open Sans" pitchFamily="34" charset="-120"/>
+              </a:rPr>
+              <a:t>4</a:t>
             </a:r>
             <a:endParaRPr lang="en-US" sz="2200" dirty="0"/>
           </a:p>
@@ -4437,14 +6595,14 @@
       </p:sp>
       <p:sp>
         <p:nvSpPr>
-          <p:cNvPr id="14" name="Text 12"/>
-          <p:cNvSpPr/>
-          <p:nvPr/>
-        </p:nvSpPr>
-        <p:spPr>
-          <a:xfrm>
-            <a:off x="1280160" y="3246120"/>
-            <a:ext cx="4937760" cy="365760"/>
+          <p:cNvPr id="18" name="Text 16"/>
+          <p:cNvSpPr/>
+          <p:nvPr/>
+        </p:nvSpPr>
+        <p:spPr>
+          <a:xfrm>
+            <a:off x="1280160" y="4251960"/>
+            <a:ext cx="5120640" cy="365760"/>
           </a:xfrm>
           <a:prstGeom prst="rect">
             <a:avLst/>
@@ -4460,30 +6618,30 @@
               <a:buNone/>
             </a:pPr>
             <a:r>
-              <a:rPr lang="en-US" sz="1700" b="1" dirty="0">
-                <a:solidFill>
-                  <a:srgbClr val="FFFFFF"/>
-                </a:solidFill>
-                <a:latin typeface="Open Sans" pitchFamily="34" charset="0"/>
-                <a:ea typeface="Open Sans" pitchFamily="34" charset="-122"/>
-                <a:cs typeface="Open Sans" pitchFamily="34" charset="-120"/>
-              </a:rPr>
-              <a:t>CI/CD no GitLab</a:t>
-            </a:r>
-            <a:endParaRPr lang="en-US" sz="1700" dirty="0"/>
-          </a:p>
-        </p:txBody>
-      </p:sp>
-      <p:sp>
-        <p:nvSpPr>
-          <p:cNvPr id="15" name="Text 13"/>
-          <p:cNvSpPr/>
-          <p:nvPr/>
-        </p:nvSpPr>
-        <p:spPr>
-          <a:xfrm>
-            <a:off x="1280160" y="3593592"/>
-            <a:ext cx="5120640" cy="457200"/>
+              <a:rPr lang="en-US" sz="1600" b="1" dirty="0">
+                <a:solidFill>
+                  <a:srgbClr val="212A31"/>
+                </a:solidFill>
+                <a:latin typeface="Open Sans" pitchFamily="34" charset="0"/>
+                <a:ea typeface="Open Sans" pitchFamily="34" charset="-122"/>
+                <a:cs typeface="Open Sans" pitchFamily="34" charset="-120"/>
+              </a:rPr>
+              <a:t>Aval para virar o site oficial</a:t>
+            </a:r>
+            <a:endParaRPr lang="en-US" sz="1600" dirty="0"/>
+          </a:p>
+        </p:txBody>
+      </p:sp>
+      <p:sp>
+        <p:nvSpPr>
+          <p:cNvPr id="19" name="Text 17"/>
+          <p:cNvSpPr/>
+          <p:nvPr/>
+        </p:nvSpPr>
+        <p:spPr>
+          <a:xfrm>
+            <a:off x="1280160" y="4599432"/>
+            <a:ext cx="5303520" cy="502920"/>
           </a:xfrm>
           <a:prstGeom prst="rect">
             <a:avLst/>
@@ -4499,154 +6657,17 @@
               <a:buNone/>
             </a:pPr>
             <a:r>
-              <a:rPr lang="en-US" sz="1250" dirty="0">
-                <a:solidFill>
-                  <a:srgbClr val="CCDCEC"/>
-                </a:solidFill>
-                <a:latin typeface="Open Sans" pitchFamily="34" charset="0"/>
-                <a:ea typeface="Open Sans" pitchFamily="34" charset="-122"/>
-                <a:cs typeface="Open Sans" pitchFamily="34" charset="-120"/>
-              </a:rPr>
-              <a:t>Build automático + gate de acessibilidade (eMAG/WCAG).</a:t>
-            </a:r>
-            <a:endParaRPr lang="en-US" sz="1250" dirty="0"/>
-          </a:p>
-        </p:txBody>
-      </p:sp>
-      <p:sp>
-        <p:nvSpPr>
-          <p:cNvPr id="16" name="Shape 14"/>
-          <p:cNvSpPr/>
-          <p:nvPr/>
-        </p:nvSpPr>
-        <p:spPr>
-          <a:xfrm>
-            <a:off x="594360" y="4206240"/>
-            <a:ext cx="502920" cy="502920"/>
-          </a:xfrm>
-          <a:prstGeom prst="ellipse">
-            <a:avLst/>
-          </a:prstGeom>
-          <a:solidFill>
-            <a:srgbClr val="FFFFFF"/>
-          </a:solidFill>
-          <a:ln/>
-        </p:spPr>
-      </p:sp>
-      <p:sp>
-        <p:nvSpPr>
-          <p:cNvPr id="17" name="Text 15"/>
-          <p:cNvSpPr/>
-          <p:nvPr/>
-        </p:nvSpPr>
-        <p:spPr>
-          <a:xfrm>
-            <a:off x="594360" y="4206240"/>
-            <a:ext cx="502920" cy="502920"/>
-          </a:xfrm>
-          <a:prstGeom prst="rect">
-            <a:avLst/>
-          </a:prstGeom>
-          <a:noFill/>
-          <a:ln/>
-        </p:spPr>
-        <p:txBody>
-          <a:bodyPr wrap="square" lIns="0" tIns="0" rIns="0" bIns="0" rtlCol="0" anchor="ctr"/>
-          <a:lstStyle/>
-          <a:p>
-            <a:pPr marL="0" indent="0" algn="ctr">
-              <a:buNone/>
-            </a:pPr>
-            <a:r>
-              <a:rPr lang="en-US" sz="2200" b="1" dirty="0">
-                <a:solidFill>
-                  <a:srgbClr val="004F9F"/>
-                </a:solidFill>
-                <a:latin typeface="Open Sans" pitchFamily="34" charset="0"/>
-                <a:ea typeface="Open Sans" pitchFamily="34" charset="-122"/>
-                <a:cs typeface="Open Sans" pitchFamily="34" charset="-120"/>
-              </a:rPr>
-              <a:t>4</a:t>
-            </a:r>
-            <a:endParaRPr lang="en-US" sz="2200" dirty="0"/>
-          </a:p>
-        </p:txBody>
-      </p:sp>
-      <p:sp>
-        <p:nvSpPr>
-          <p:cNvPr id="18" name="Text 16"/>
-          <p:cNvSpPr/>
-          <p:nvPr/>
-        </p:nvSpPr>
-        <p:spPr>
-          <a:xfrm>
-            <a:off x="1280160" y="4160520"/>
-            <a:ext cx="4937760" cy="365760"/>
-          </a:xfrm>
-          <a:prstGeom prst="rect">
-            <a:avLst/>
-          </a:prstGeom>
-          <a:noFill/>
-          <a:ln/>
-        </p:spPr>
-        <p:txBody>
-          <a:bodyPr wrap="square" lIns="0" tIns="0" rIns="0" bIns="0" rtlCol="0" anchor="ctr"/>
-          <a:lstStyle/>
-          <a:p>
-            <a:pPr marL="0" indent="0">
-              <a:buNone/>
-            </a:pPr>
-            <a:r>
-              <a:rPr lang="en-US" sz="1700" b="1" dirty="0">
-                <a:solidFill>
-                  <a:srgbClr val="FFFFFF"/>
-                </a:solidFill>
-                <a:latin typeface="Open Sans" pitchFamily="34" charset="0"/>
-                <a:ea typeface="Open Sans" pitchFamily="34" charset="-122"/>
-                <a:cs typeface="Open Sans" pitchFamily="34" charset="-120"/>
-              </a:rPr>
-              <a:t>Publicar o Storybook</a:t>
-            </a:r>
-            <a:endParaRPr lang="en-US" sz="1700" dirty="0"/>
-          </a:p>
-        </p:txBody>
-      </p:sp>
-      <p:sp>
-        <p:nvSpPr>
-          <p:cNvPr id="19" name="Text 17"/>
-          <p:cNvSpPr/>
-          <p:nvPr/>
-        </p:nvSpPr>
-        <p:spPr>
-          <a:xfrm>
-            <a:off x="1280160" y="4507992"/>
-            <a:ext cx="5120640" cy="457200"/>
-          </a:xfrm>
-          <a:prstGeom prst="rect">
-            <a:avLst/>
-          </a:prstGeom>
-          <a:noFill/>
-          <a:ln/>
-        </p:spPr>
-        <p:txBody>
-          <a:bodyPr wrap="square" lIns="0" tIns="0" rIns="0" bIns="0" rtlCol="0" anchor="ctr"/>
-          <a:lstStyle/>
-          <a:p>
-            <a:pPr marL="0" indent="0">
-              <a:buNone/>
-            </a:pPr>
-            <a:r>
-              <a:rPr lang="en-US" sz="1250" dirty="0">
-                <a:solidFill>
-                  <a:srgbClr val="CCDCEC"/>
-                </a:solidFill>
-                <a:latin typeface="Open Sans" pitchFamily="34" charset="0"/>
-                <a:ea typeface="Open Sans" pitchFamily="34" charset="-122"/>
-                <a:cs typeface="Open Sans" pitchFamily="34" charset="-120"/>
-              </a:rPr>
-              <a:t>Vira o novo site — aposenta as imagens estáticas.</a:t>
-            </a:r>
-            <a:endParaRPr lang="en-US" sz="1250" dirty="0"/>
+              <a:rPr lang="en-US" sz="1200" dirty="0">
+                <a:solidFill>
+                  <a:srgbClr val="545D64"/>
+                </a:solidFill>
+                <a:latin typeface="Open Sans" pitchFamily="34" charset="0"/>
+                <a:ea typeface="Open Sans" pitchFamily="34" charset="-122"/>
+                <a:cs typeface="Open Sans" pitchFamily="34" charset="-120"/>
+              </a:rPr>
+              <a:t>Storybook publicado pode substituir designsystem.ms.gov.br.</a:t>
+            </a:r>
+            <a:endParaRPr lang="en-US" sz="1200" dirty="0"/>
           </a:p>
         </p:txBody>
       </p:sp>
@@ -4658,16 +6679,21 @@
         </p:nvSpPr>
         <p:spPr>
           <a:xfrm>
-            <a:off x="6858000" y="1463040"/>
-            <a:ext cx="4754880" cy="2743200"/>
-          </a:xfrm>
-          <a:prstGeom prst="rect">
-            <a:avLst/>
-          </a:prstGeom>
-          <a:solidFill>
-            <a:srgbClr val="FFFFFF"/>
-          </a:solidFill>
-          <a:ln/>
+            <a:off x="6949440" y="1417320"/>
+            <a:ext cx="4709160" cy="3383280"/>
+          </a:xfrm>
+          <a:prstGeom prst="rect">
+            <a:avLst/>
+          </a:prstGeom>
+          <a:solidFill>
+            <a:srgbClr val="F6F8FB"/>
+          </a:solidFill>
+          <a:ln w="12700">
+            <a:solidFill>
+              <a:srgbClr val="D4D7D8"/>
+            </a:solidFill>
+            <a:prstDash val="solid"/>
+          </a:ln>
           <a:effectLst>
             <a:outerShdw blurRad="88900" dist="38100" dir="8100000" algn="bl" rotWithShape="0">
               <a:srgbClr val="000000">
@@ -4685,14 +6711,14 @@
         </p:nvSpPr>
         <p:spPr>
           <a:xfrm>
-            <a:off x="6858000" y="1463040"/>
-            <a:ext cx="4754880" cy="109728"/>
-          </a:xfrm>
-          <a:prstGeom prst="rect">
-            <a:avLst/>
-          </a:prstGeom>
-          <a:solidFill>
-            <a:srgbClr val="CCDCEC"/>
+            <a:off x="6949440" y="1417320"/>
+            <a:ext cx="4709160" cy="109728"/>
+          </a:xfrm>
+          <a:prstGeom prst="rect">
+            <a:avLst/>
+          </a:prstGeom>
+          <a:solidFill>
+            <a:srgbClr val="004F9F"/>
           </a:solidFill>
           <a:ln/>
         </p:spPr>
@@ -4705,8 +6731,8 @@
         </p:nvSpPr>
         <p:spPr>
           <a:xfrm>
-            <a:off x="7086600" y="1691640"/>
-            <a:ext cx="4297680" cy="411480"/>
+            <a:off x="7178040" y="1645920"/>
+            <a:ext cx="4297680" cy="365760"/>
           </a:xfrm>
           <a:prstGeom prst="rect">
             <a:avLst/>
@@ -4722,7 +6748,7 @@
               <a:buNone/>
             </a:pPr>
             <a:r>
-              <a:rPr lang="en-US" sz="1800" b="1" dirty="0">
+              <a:rPr lang="en-US" sz="1600" b="1" dirty="0">
                 <a:solidFill>
                   <a:srgbClr val="004F9F"/>
                 </a:solidFill>
@@ -4730,9 +6756,9 @@
                 <a:ea typeface="Open Sans" pitchFamily="34" charset="-122"/>
                 <a:cs typeface="Open Sans" pitchFamily="34" charset="-120"/>
               </a:rPr>
-              <a:t>O que precisamos</a:t>
-            </a:r>
-            <a:endParaRPr lang="en-US" sz="1800" dirty="0"/>
+              <a:t>Já não precisamos pedir</a:t>
+            </a:r>
+            <a:endParaRPr lang="en-US" sz="1600" dirty="0"/>
           </a:p>
         </p:txBody>
       </p:sp>
@@ -4744,8 +6770,8 @@
         </p:nvSpPr>
         <p:spPr>
           <a:xfrm>
-            <a:off x="7086600" y="2194560"/>
-            <a:ext cx="4297680" cy="1828800"/>
+            <a:off x="7178040" y="2103120"/>
+            <a:ext cx="4297680" cy="1005840"/>
           </a:xfrm>
           <a:prstGeom prst="rect">
             <a:avLst/>
@@ -4759,13 +6785,13 @@
           <a:p>
             <a:pPr marL="342900" indent="-342900">
               <a:spcAft>
-                <a:spcPts val="1000"/>
+                <a:spcPts val="800"/>
               </a:spcAft>
               <a:buSzPct val="100000"/>
               <a:buChar char="•"/>
             </a:pPr>
             <a:r>
-              <a:rPr lang="en-US" sz="1350" dirty="0">
+              <a:rPr lang="en-US" sz="1250" dirty="0">
                 <a:solidFill>
                   <a:srgbClr val="212A31"/>
                 </a:solidFill>
@@ -4773,20 +6799,20 @@
                 <a:ea typeface="Open Sans" pitchFamily="34" charset="-122"/>
                 <a:cs typeface="Open Sans" pitchFamily="34" charset="-120"/>
               </a:rPr>
-              <a:t>Acesso ao Figma (Tokens Studio) e ao repositório GitLab do DS.</a:t>
-            </a:r>
-            <a:endParaRPr lang="en-US" sz="1350" dirty="0"/>
+              <a:t>Orçamento de infraestrutura — está em R$ 0/mês.</a:t>
+            </a:r>
+            <a:endParaRPr lang="en-US" sz="1250" dirty="0"/>
           </a:p>
           <a:p>
             <a:pPr marL="342900" indent="-342900">
               <a:spcAft>
-                <a:spcPts val="1000"/>
+                <a:spcPts val="800"/>
               </a:spcAft>
               <a:buSzPct val="100000"/>
               <a:buChar char="•"/>
             </a:pPr>
             <a:r>
-              <a:rPr lang="en-US" sz="1350" dirty="0">
+              <a:rPr lang="en-US" sz="1250" dirty="0">
                 <a:solidFill>
                   <a:srgbClr val="212A31"/>
                 </a:solidFill>
@@ -4794,20 +6820,81 @@
                 <a:ea typeface="Open Sans" pitchFamily="34" charset="-122"/>
                 <a:cs typeface="Open Sans" pitchFamily="34" charset="-120"/>
               </a:rPr>
-              <a:t>Aval para evoluir a POC em um piloto oficial.</a:t>
-            </a:r>
-            <a:endParaRPr lang="en-US" sz="1350" dirty="0"/>
-          </a:p>
+              <a:t>Aprovar tecnologia — Storybook/npm já validados em produção.</a:t>
+            </a:r>
+            <a:endParaRPr lang="en-US" sz="1250" dirty="0"/>
+          </a:p>
+        </p:txBody>
+      </p:sp>
+      <p:sp>
+        <p:nvSpPr>
+          <p:cNvPr id="24" name="Text 22"/>
+          <p:cNvSpPr/>
+          <p:nvPr/>
+        </p:nvSpPr>
+        <p:spPr>
+          <a:xfrm>
+            <a:off x="7178040" y="3246120"/>
+            <a:ext cx="4297680" cy="365760"/>
+          </a:xfrm>
+          <a:prstGeom prst="rect">
+            <a:avLst/>
+          </a:prstGeom>
+          <a:noFill/>
+          <a:ln/>
+        </p:spPr>
+        <p:txBody>
+          <a:bodyPr wrap="square" lIns="0" tIns="0" rIns="0" bIns="0" rtlCol="0" anchor="ctr"/>
+          <a:lstStyle/>
+          <a:p>
+            <a:pPr marL="0" indent="0">
+              <a:buNone/>
+            </a:pPr>
+            <a:r>
+              <a:rPr lang="en-US" sz="1600" b="1" dirty="0">
+                <a:solidFill>
+                  <a:srgbClr val="004F9F"/>
+                </a:solidFill>
+                <a:latin typeface="Open Sans" pitchFamily="34" charset="0"/>
+                <a:ea typeface="Open Sans" pitchFamily="34" charset="-122"/>
+                <a:cs typeface="Open Sans" pitchFamily="34" charset="-120"/>
+              </a:rPr>
+              <a:t>O que precisamos</a:t>
+            </a:r>
+            <a:endParaRPr lang="en-US" sz="1600" dirty="0"/>
+          </a:p>
+        </p:txBody>
+      </p:sp>
+      <p:sp>
+        <p:nvSpPr>
+          <p:cNvPr id="25" name="Text 23"/>
+          <p:cNvSpPr/>
+          <p:nvPr/>
+        </p:nvSpPr>
+        <p:spPr>
+          <a:xfrm>
+            <a:off x="7178040" y="3703320"/>
+            <a:ext cx="4297680" cy="914400"/>
+          </a:xfrm>
+          <a:prstGeom prst="rect">
+            <a:avLst/>
+          </a:prstGeom>
+          <a:noFill/>
+          <a:ln/>
+        </p:spPr>
+        <p:txBody>
+          <a:bodyPr wrap="square" lIns="0" tIns="0" rIns="0" bIns="0" rtlCol="0" anchor="ctr"/>
+          <a:lstStyle/>
           <a:p>
             <a:pPr marL="342900" indent="-342900">
               <a:spcAft>
-                <a:spcPts val="1000"/>
+                <a:spcPts val="800"/>
               </a:spcAft>
               <a:buSzPct val="100000"/>
               <a:buChar char="•"/>
             </a:pPr>
             <a:r>
-              <a:rPr lang="en-US" sz="1350" dirty="0">
+              <a:rPr lang="en-US" sz="1250" dirty="0">
                 <a:solidFill>
                   <a:srgbClr val="212A31"/>
                 </a:solidFill>
@@ -4815,38 +6902,79 @@
                 <a:ea typeface="Open Sans" pitchFamily="34" charset="-122"/>
                 <a:cs typeface="Open Sans" pitchFamily="34" charset="-120"/>
               </a:rPr>
-              <a:t>Definição de quem mantém (SGD) e como os times contribuem.</a:t>
-            </a:r>
-            <a:endParaRPr lang="en-US" sz="1350" dirty="0"/>
-          </a:p>
-        </p:txBody>
-      </p:sp>
-      <p:sp>
-        <p:nvSpPr>
-          <p:cNvPr id="24" name="Text 22"/>
-          <p:cNvSpPr/>
-          <p:nvPr/>
-        </p:nvSpPr>
-        <p:spPr>
-          <a:xfrm>
-            <a:off x="548640" y="5577840"/>
-            <a:ext cx="10972800" cy="457200"/>
-          </a:xfrm>
-          <a:prstGeom prst="rect">
-            <a:avLst/>
-          </a:prstGeom>
-          <a:noFill/>
-          <a:ln/>
-        </p:spPr>
-        <p:txBody>
-          <a:bodyPr wrap="square" lIns="0" tIns="0" rIns="0" bIns="0" rtlCol="0" anchor="ctr"/>
-          <a:lstStyle/>
-          <a:p>
-            <a:pPr marL="0" indent="0">
-              <a:buNone/>
-            </a:pPr>
-            <a:r>
-              <a:rPr lang="en-US" sz="1700" b="1" i="1" dirty="0">
+              <a:t>Acesso ao Figma oficial do DS-MS (Tokens Studio).</a:t>
+            </a:r>
+            <a:endParaRPr lang="en-US" sz="1250" dirty="0"/>
+          </a:p>
+          <a:p>
+            <a:pPr marL="342900" indent="-342900">
+              <a:spcAft>
+                <a:spcPts val="800"/>
+              </a:spcAft>
+              <a:buSzPct val="100000"/>
+              <a:buChar char="•"/>
+            </a:pPr>
+            <a:r>
+              <a:rPr lang="en-US" sz="1250" dirty="0">
+                <a:solidFill>
+                  <a:srgbClr val="212A31"/>
+                </a:solidFill>
+                <a:latin typeface="Open Sans" pitchFamily="34" charset="0"/>
+                <a:ea typeface="Open Sans" pitchFamily="34" charset="-122"/>
+                <a:cs typeface="Open Sans" pitchFamily="34" charset="-120"/>
+              </a:rPr>
+              <a:t>Aval para evoluir o pacote em piloto oficial da SETDIG.</a:t>
+            </a:r>
+            <a:endParaRPr lang="en-US" sz="1250" dirty="0"/>
+          </a:p>
+        </p:txBody>
+      </p:sp>
+      <p:sp>
+        <p:nvSpPr>
+          <p:cNvPr id="26" name="Shape 24"/>
+          <p:cNvSpPr/>
+          <p:nvPr/>
+        </p:nvSpPr>
+        <p:spPr>
+          <a:xfrm>
+            <a:off x="548640" y="5486400"/>
+            <a:ext cx="11091672" cy="640080"/>
+          </a:xfrm>
+          <a:prstGeom prst="rect">
+            <a:avLst/>
+          </a:prstGeom>
+          <a:solidFill>
+            <a:srgbClr val="004F9F"/>
+          </a:solidFill>
+          <a:ln/>
+        </p:spPr>
+      </p:sp>
+      <p:sp>
+        <p:nvSpPr>
+          <p:cNvPr id="27" name="Text 25"/>
+          <p:cNvSpPr/>
+          <p:nvPr/>
+        </p:nvSpPr>
+        <p:spPr>
+          <a:xfrm>
+            <a:off x="548640" y="5486400"/>
+            <a:ext cx="11091672" cy="640080"/>
+          </a:xfrm>
+          <a:prstGeom prst="rect">
+            <a:avLst/>
+          </a:prstGeom>
+          <a:noFill/>
+          <a:ln/>
+        </p:spPr>
+        <p:txBody>
+          <a:bodyPr wrap="square" lIns="0" tIns="0" rIns="0" bIns="0" rtlCol="0" anchor="ctr"/>
+          <a:lstStyle/>
+          <a:p>
+            <a:pPr marL="0" indent="0" algn="ctr">
+              <a:buNone/>
+            </a:pPr>
+            <a:r>
+              <a:rPr lang="en-US" sz="1600" b="1" i="1" dirty="0">
                 <a:solidFill>
                   <a:srgbClr val="FFFFFF"/>
                 </a:solidFill>
@@ -4856,13 +6984,13 @@
               </a:rPr>
               <a:t>Um passo pequeno agora evita um gargalo grande depois.</a:t>
             </a:r>
-            <a:endParaRPr lang="en-US" sz="1700" dirty="0"/>
-          </a:p>
-        </p:txBody>
-      </p:sp>
-      <p:sp>
-        <p:nvSpPr>
-          <p:cNvPr id="25" name="Text 23"/>
+            <a:endParaRPr lang="en-US" sz="1600" dirty="0"/>
+          </a:p>
+        </p:txBody>
+      </p:sp>
+      <p:sp>
+        <p:nvSpPr>
+          <p:cNvPr id="28" name="Text 26"/>
           <p:cNvSpPr/>
           <p:nvPr/>
         </p:nvSpPr>
@@ -4887,7 +7015,7 @@
             <a:r>
               <a:rPr lang="en-US" sz="900" dirty="0">
                 <a:solidFill>
-                  <a:srgbClr val="CCDCEC"/>
+                  <a:srgbClr val="545D64"/>
                 </a:solidFill>
                 <a:latin typeface="Open Sans" pitchFamily="34" charset="0"/>
                 <a:ea typeface="Open Sans" pitchFamily="34" charset="-122"/>
@@ -4901,14 +7029,14 @@
       </p:sp>
       <p:sp>
         <p:nvSpPr>
-          <p:cNvPr id="26" name="Text 24"/>
-          <p:cNvSpPr/>
-          <p:nvPr/>
-        </p:nvSpPr>
-        <p:spPr>
-          <a:xfrm>
-            <a:off x="11338560" y="6446520"/>
-            <a:ext cx="457200" cy="274320"/>
+          <p:cNvPr id="29" name="Text 27"/>
+          <p:cNvSpPr/>
+          <p:nvPr/>
+        </p:nvSpPr>
+        <p:spPr>
+          <a:xfrm>
+            <a:off x="11064240" y="6446520"/>
+            <a:ext cx="731520" cy="274320"/>
           </a:xfrm>
           <a:prstGeom prst="rect">
             <a:avLst/>
@@ -4926,13 +7054,13 @@
             <a:r>
               <a:rPr lang="en-US" sz="900" dirty="0">
                 <a:solidFill>
-                  <a:srgbClr val="CCDCEC"/>
-                </a:solidFill>
-                <a:latin typeface="Open Sans" pitchFamily="34" charset="0"/>
-                <a:ea typeface="Open Sans" pitchFamily="34" charset="-122"/>
-                <a:cs typeface="Open Sans" pitchFamily="34" charset="-120"/>
-              </a:rPr>
-              <a:t>05</a:t>
+                  <a:srgbClr val="545D64"/>
+                </a:solidFill>
+                <a:latin typeface="Open Sans" pitchFamily="34" charset="0"/>
+                <a:ea typeface="Open Sans" pitchFamily="34" charset="-122"/>
+                <a:cs typeface="Open Sans" pitchFamily="34" charset="-120"/>
+              </a:rPr>
+              <a:t>07 / 7</a:t>
             </a:r>
             <a:endParaRPr lang="en-US" sz="900" dirty="0"/>
           </a:p>
@@ -4943,13 +7071,6 @@
   <p:clrMapOvr>
     <a:masterClrMapping/>
   </p:clrMapOvr>
-  <p:timing>
-    <p:tnLst>
-      <p:par>
-        <p:cTn id="1" dur="indefinite" restart="never" nodeType="tmRoot"/>
-      </p:par>
-    </p:tnLst>
-  </p:timing>
 </p:sld>
 </file>
 

</xml_diff>